<commit_message>
Update day 1 slides
</commit_message>
<xml_diff>
--- a/modules/week01/slides-01.pptx
+++ b/modules/week01/slides-01.pptx
@@ -6,7 +6,7 @@
     <p:sldMasterId id="2147483673" r:id="rId2"/>
   </p:sldMasterIdLst>
   <p:notesMasterIdLst>
-    <p:notesMasterId r:id="rId49"/>
+    <p:notesMasterId r:id="rId50"/>
   </p:notesMasterIdLst>
   <p:sldIdLst>
     <p:sldId id="256" r:id="rId3"/>
@@ -27,71 +27,72 @@
     <p:sldId id="273" r:id="rId18"/>
     <p:sldId id="275" r:id="rId19"/>
     <p:sldId id="293" r:id="rId20"/>
-    <p:sldId id="294" r:id="rId21"/>
-    <p:sldId id="295" r:id="rId22"/>
-    <p:sldId id="302" r:id="rId23"/>
-    <p:sldId id="303" r:id="rId24"/>
-    <p:sldId id="298" r:id="rId25"/>
-    <p:sldId id="296" r:id="rId26"/>
-    <p:sldId id="299" r:id="rId27"/>
-    <p:sldId id="277" r:id="rId28"/>
-    <p:sldId id="301" r:id="rId29"/>
-    <p:sldId id="281" r:id="rId30"/>
-    <p:sldId id="279" r:id="rId31"/>
-    <p:sldId id="282" r:id="rId32"/>
-    <p:sldId id="283" r:id="rId33"/>
-    <p:sldId id="284" r:id="rId34"/>
-    <p:sldId id="278" r:id="rId35"/>
-    <p:sldId id="268" r:id="rId36"/>
-    <p:sldId id="304" r:id="rId37"/>
-    <p:sldId id="297" r:id="rId38"/>
-    <p:sldId id="270" r:id="rId39"/>
-    <p:sldId id="271" r:id="rId40"/>
-    <p:sldId id="286" r:id="rId41"/>
-    <p:sldId id="285" r:id="rId42"/>
-    <p:sldId id="291" r:id="rId43"/>
-    <p:sldId id="292" r:id="rId44"/>
-    <p:sldId id="287" r:id="rId45"/>
-    <p:sldId id="290" r:id="rId46"/>
-    <p:sldId id="272" r:id="rId47"/>
-    <p:sldId id="288" r:id="rId48"/>
+    <p:sldId id="305" r:id="rId21"/>
+    <p:sldId id="294" r:id="rId22"/>
+    <p:sldId id="295" r:id="rId23"/>
+    <p:sldId id="302" r:id="rId24"/>
+    <p:sldId id="303" r:id="rId25"/>
+    <p:sldId id="298" r:id="rId26"/>
+    <p:sldId id="296" r:id="rId27"/>
+    <p:sldId id="299" r:id="rId28"/>
+    <p:sldId id="277" r:id="rId29"/>
+    <p:sldId id="301" r:id="rId30"/>
+    <p:sldId id="281" r:id="rId31"/>
+    <p:sldId id="279" r:id="rId32"/>
+    <p:sldId id="282" r:id="rId33"/>
+    <p:sldId id="283" r:id="rId34"/>
+    <p:sldId id="284" r:id="rId35"/>
+    <p:sldId id="278" r:id="rId36"/>
+    <p:sldId id="268" r:id="rId37"/>
+    <p:sldId id="304" r:id="rId38"/>
+    <p:sldId id="297" r:id="rId39"/>
+    <p:sldId id="270" r:id="rId40"/>
+    <p:sldId id="271" r:id="rId41"/>
+    <p:sldId id="286" r:id="rId42"/>
+    <p:sldId id="285" r:id="rId43"/>
+    <p:sldId id="291" r:id="rId44"/>
+    <p:sldId id="292" r:id="rId45"/>
+    <p:sldId id="287" r:id="rId46"/>
+    <p:sldId id="290" r:id="rId47"/>
+    <p:sldId id="272" r:id="rId48"/>
+    <p:sldId id="288" r:id="rId49"/>
   </p:sldIdLst>
   <p:sldSz cx="9144000" cy="5143500" type="screen16x9"/>
   <p:notesSz cx="6858000" cy="9144000"/>
   <p:embeddedFontLst>
     <p:embeddedFont>
       <p:font typeface="Avenir" panose="02000503020000020003" pitchFamily="2" charset="0"/>
-      <p:regular r:id="rId50"/>
-      <p:italic r:id="rId51"/>
+      <p:regular r:id="rId51"/>
+      <p:italic r:id="rId52"/>
     </p:embeddedFont>
     <p:embeddedFont>
       <p:font typeface="Avenir Black" panose="02000503020000020003" pitchFamily="2" charset="0"/>
-      <p:bold r:id="rId52"/>
-      <p:italic r:id="rId53"/>
-      <p:boldItalic r:id="rId54"/>
+      <p:bold r:id="rId53"/>
+      <p:italic r:id="rId54"/>
+      <p:boldItalic r:id="rId55"/>
     </p:embeddedFont>
     <p:embeddedFont>
       <p:font typeface="Avenir Book" panose="02000503020000020003" pitchFamily="2" charset="0"/>
-      <p:regular r:id="rId55"/>
-      <p:italic r:id="rId56"/>
+      <p:regular r:id="rId56"/>
+      <p:italic r:id="rId57"/>
     </p:embeddedFont>
     <p:embeddedFont>
       <p:font typeface="Century Gothic" panose="020B0502020202020204" pitchFamily="34" charset="0"/>
-      <p:regular r:id="rId57"/>
-      <p:bold r:id="rId58"/>
-      <p:italic r:id="rId59"/>
-      <p:boldItalic r:id="rId60"/>
+      <p:regular r:id="rId58"/>
+      <p:bold r:id="rId59"/>
+      <p:italic r:id="rId60"/>
+      <p:boldItalic r:id="rId61"/>
     </p:embeddedFont>
     <p:embeddedFont>
       <p:font typeface="Lobster" pitchFamily="2" charset="77"/>
-      <p:regular r:id="rId61"/>
+      <p:regular r:id="rId62"/>
     </p:embeddedFont>
     <p:embeddedFont>
       <p:font typeface="Nunito Sans" pitchFamily="2" charset="77"/>
-      <p:regular r:id="rId62"/>
-      <p:bold r:id="rId63"/>
-      <p:italic r:id="rId64"/>
-      <p:boldItalic r:id="rId65"/>
+      <p:regular r:id="rId63"/>
+      <p:bold r:id="rId64"/>
+      <p:italic r:id="rId65"/>
+      <p:boldItalic r:id="rId66"/>
     </p:embeddedFont>
   </p:embeddedFontLst>
   <p:defaultTextStyle>
@@ -1396,7 +1397,13 @@
   <p:cSld>
     <p:spTree>
       <p:nvGrpSpPr>
-        <p:cNvPr id="1" name=""/>
+        <p:cNvPr id="1" name="">
+          <a:extLst>
+            <a:ext uri="{FF2B5EF4-FFF2-40B4-BE49-F238E27FC236}">
+              <a16:creationId xmlns:a16="http://schemas.microsoft.com/office/drawing/2014/main" id="{CE66D2DD-D434-D25E-9E8A-C7F624DE4BDF}"/>
+            </a:ext>
+          </a:extLst>
+        </p:cNvPr>
         <p:cNvGrpSpPr/>
         <p:nvPr/>
       </p:nvGrpSpPr>
@@ -1410,7 +1417,13 @@
       </p:grpSpPr>
       <p:sp>
         <p:nvSpPr>
-          <p:cNvPr id="2" name="Slide Image Placeholder 1"/>
+          <p:cNvPr id="2" name="Slide Image Placeholder 1">
+            <a:extLst>
+              <a:ext uri="{FF2B5EF4-FFF2-40B4-BE49-F238E27FC236}">
+                <a16:creationId xmlns:a16="http://schemas.microsoft.com/office/drawing/2014/main" id="{9C1A7611-8A5F-D70F-3A7D-4C41B50C26CA}"/>
+              </a:ext>
+            </a:extLst>
+          </p:cNvPr>
           <p:cNvSpPr>
             <a:spLocks noGrp="1" noRot="1" noChangeAspect="1"/>
           </p:cNvSpPr>
@@ -1418,11 +1431,22 @@
             <p:ph type="sldImg"/>
           </p:nvPr>
         </p:nvSpPr>
-        <p:spPr/>
+        <p:spPr>
+          <a:xfrm>
+            <a:off x="381000" y="685800"/>
+            <a:ext cx="6096000" cy="3429000"/>
+          </a:xfrm>
+        </p:spPr>
       </p:sp>
       <p:sp>
         <p:nvSpPr>
-          <p:cNvPr id="3" name="Notes Placeholder 2"/>
+          <p:cNvPr id="3" name="Notes Placeholder 2">
+            <a:extLst>
+              <a:ext uri="{FF2B5EF4-FFF2-40B4-BE49-F238E27FC236}">
+                <a16:creationId xmlns:a16="http://schemas.microsoft.com/office/drawing/2014/main" id="{497ABF92-97FA-EE2A-B915-64618E264EA5}"/>
+              </a:ext>
+            </a:extLst>
+          </p:cNvPr>
           <p:cNvSpPr>
             <a:spLocks noGrp="1"/>
           </p:cNvSpPr>
@@ -1435,14 +1459,23 @@
           <a:bodyPr/>
           <a:lstStyle/>
           <a:p>
-            <a:endParaRPr lang="en-US" dirty="0"/>
+            <a:r>
+              <a:rPr lang="en-US" dirty="0"/>
+              <a:t>NCEAS: concise document that summarizes a lot of what we’re talking about</a:t>
+            </a:r>
+          </a:p>
+          <a:p>
+            <a:r>
+              <a:rPr lang="en-US" dirty="0"/>
+              <a:t>Wohner: good window into the challenges of data modeling</a:t>
+            </a:r>
           </a:p>
         </p:txBody>
       </p:sp>
     </p:spTree>
     <p:extLst>
       <p:ext uri="{BB962C8B-B14F-4D97-AF65-F5344CB8AC3E}">
-        <p14:creationId xmlns:p14="http://schemas.microsoft.com/office/powerpoint/2010/main" val="770618553"/>
+        <p14:creationId xmlns:p14="http://schemas.microsoft.com/office/powerpoint/2010/main" val="866801371"/>
       </p:ext>
     </p:extLst>
   </p:cSld>
@@ -1501,17 +1534,14 @@
           <a:bodyPr/>
           <a:lstStyle/>
           <a:p>
-            <a:r>
-              <a:rPr lang="en-US" dirty="0"/>
-              <a:t>Correctness/consistency preservation means that the database will not allow the row to be deleted.</a:t>
-            </a:r>
+            <a:endParaRPr lang="en-US" dirty="0"/>
           </a:p>
         </p:txBody>
       </p:sp>
     </p:spTree>
     <p:extLst>
       <p:ext uri="{BB962C8B-B14F-4D97-AF65-F5344CB8AC3E}">
-        <p14:creationId xmlns:p14="http://schemas.microsoft.com/office/powerpoint/2010/main" val="2050531551"/>
+        <p14:creationId xmlns:p14="http://schemas.microsoft.com/office/powerpoint/2010/main" val="770618553"/>
       </p:ext>
     </p:extLst>
   </p:cSld>
@@ -1572,7 +1602,7 @@
           <a:p>
             <a:r>
               <a:rPr lang="en-US" dirty="0"/>
-              <a:t>Student question: Enrollment is not human readable, very technical</a:t>
+              <a:t>Correctness/consistency preservation means that the database will not allow the row to be deleted.</a:t>
             </a:r>
           </a:p>
         </p:txBody>
@@ -1580,7 +1610,7 @@
     </p:spTree>
     <p:extLst>
       <p:ext uri="{BB962C8B-B14F-4D97-AF65-F5344CB8AC3E}">
-        <p14:creationId xmlns:p14="http://schemas.microsoft.com/office/powerpoint/2010/main" val="2326430434"/>
+        <p14:creationId xmlns:p14="http://schemas.microsoft.com/office/powerpoint/2010/main" val="2050531551"/>
       </p:ext>
     </p:extLst>
   </p:cSld>
@@ -1744,7 +1774,7 @@
           <a:p>
             <a:r>
               <a:rPr lang="en-US" dirty="0"/>
-              <a:t>A view is a table, albeit a virtual one</a:t>
+              <a:t>Student question: Enrollment is not human readable, very technical</a:t>
             </a:r>
           </a:p>
         </p:txBody>
@@ -1752,7 +1782,7 @@
     </p:spTree>
     <p:extLst>
       <p:ext uri="{BB962C8B-B14F-4D97-AF65-F5344CB8AC3E}">
-        <p14:creationId xmlns:p14="http://schemas.microsoft.com/office/powerpoint/2010/main" val="4167947567"/>
+        <p14:creationId xmlns:p14="http://schemas.microsoft.com/office/powerpoint/2010/main" val="2326430434"/>
       </p:ext>
     </p:extLst>
   </p:cSld>
@@ -1813,7 +1843,7 @@
           <a:p>
             <a:r>
               <a:rPr lang="en-US" dirty="0"/>
-              <a:t>More formally, normalization is defined by functional dependencies between columns, and there are 5 normal forms</a:t>
+              <a:t>A view is a table, albeit a virtual one</a:t>
             </a:r>
           </a:p>
         </p:txBody>
@@ -1821,7 +1851,7 @@
     </p:spTree>
     <p:extLst>
       <p:ext uri="{BB962C8B-B14F-4D97-AF65-F5344CB8AC3E}">
-        <p14:creationId xmlns:p14="http://schemas.microsoft.com/office/powerpoint/2010/main" val="3972323475"/>
+        <p14:creationId xmlns:p14="http://schemas.microsoft.com/office/powerpoint/2010/main" val="4167947567"/>
       </p:ext>
     </p:extLst>
   </p:cSld>
@@ -1882,7 +1912,7 @@
           <a:p>
             <a:r>
               <a:rPr lang="en-US" dirty="0"/>
-              <a:t>Is headmaster an attribute of a student?  No</a:t>
+              <a:t>More formally, normalization is defined by functional dependencies between columns, and there are 5 normal forms</a:t>
             </a:r>
           </a:p>
         </p:txBody>
@@ -1890,7 +1920,7 @@
     </p:spTree>
     <p:extLst>
       <p:ext uri="{BB962C8B-B14F-4D97-AF65-F5344CB8AC3E}">
-        <p14:creationId xmlns:p14="http://schemas.microsoft.com/office/powerpoint/2010/main" val="1835519765"/>
+        <p14:creationId xmlns:p14="http://schemas.microsoft.com/office/powerpoint/2010/main" val="3972323475"/>
       </p:ext>
     </p:extLst>
   </p:cSld>
@@ -1951,7 +1981,7 @@
           <a:p>
             <a:r>
               <a:rPr lang="en-US" dirty="0"/>
-              <a:t>This assumes wand has one owner; will discuss this point further in a bit</a:t>
+              <a:t>Is headmaster an attribute of a student?  No</a:t>
             </a:r>
           </a:p>
         </p:txBody>
@@ -1959,7 +1989,7 @@
     </p:spTree>
     <p:extLst>
       <p:ext uri="{BB962C8B-B14F-4D97-AF65-F5344CB8AC3E}">
-        <p14:creationId xmlns:p14="http://schemas.microsoft.com/office/powerpoint/2010/main" val="2037729239"/>
+        <p14:creationId xmlns:p14="http://schemas.microsoft.com/office/powerpoint/2010/main" val="1835519765"/>
       </p:ext>
     </p:extLst>
   </p:cSld>
@@ -2019,25 +2049,16 @@
           <a:lstStyle/>
           <a:p>
             <a:r>
-              <a:rPr lang="en-US" dirty="0" err="1"/>
-              <a:t>Camp_staff</a:t>
-            </a:r>
-            <a:r>
               <a:rPr lang="en-US" dirty="0"/>
-              <a:t> was name originally given; renamed to </a:t>
-            </a:r>
-            <a:r>
-              <a:rPr lang="en-US" dirty="0" err="1"/>
-              <a:t>Camp_assignment</a:t>
-            </a:r>
-            <a:endParaRPr lang="en-US" dirty="0"/>
+              <a:t>This assumes wand has one owner; will discuss this point further in a bit</a:t>
+            </a:r>
           </a:p>
         </p:txBody>
       </p:sp>
     </p:spTree>
     <p:extLst>
       <p:ext uri="{BB962C8B-B14F-4D97-AF65-F5344CB8AC3E}">
-        <p14:creationId xmlns:p14="http://schemas.microsoft.com/office/powerpoint/2010/main" val="1832473117"/>
+        <p14:creationId xmlns:p14="http://schemas.microsoft.com/office/powerpoint/2010/main" val="2037729239"/>
       </p:ext>
     </p:extLst>
   </p:cSld>
@@ -2097,22 +2118,25 @@
           <a:lstStyle/>
           <a:p>
             <a:r>
+              <a:rPr lang="en-US" dirty="0" err="1"/>
+              <a:t>Camp_staff</a:t>
+            </a:r>
+            <a:r>
               <a:rPr lang="en-US" dirty="0"/>
-              <a:t>Normalization is the context of an entity type, so what the entity is determines appropriateness of attributes</a:t>
-            </a:r>
-          </a:p>
-          <a:p>
-            <a:r>
-              <a:rPr lang="en-US" dirty="0"/>
-              <a:t>Naming: what is the best name for this table/entity?</a:t>
-            </a:r>
+              <a:t> was name originally given; renamed to </a:t>
+            </a:r>
+            <a:r>
+              <a:rPr lang="en-US" dirty="0" err="1"/>
+              <a:t>Camp_assignment</a:t>
+            </a:r>
+            <a:endParaRPr lang="en-US" dirty="0"/>
           </a:p>
         </p:txBody>
       </p:sp>
     </p:spTree>
     <p:extLst>
       <p:ext uri="{BB962C8B-B14F-4D97-AF65-F5344CB8AC3E}">
-        <p14:creationId xmlns:p14="http://schemas.microsoft.com/office/powerpoint/2010/main" val="4052277560"/>
+        <p14:creationId xmlns:p14="http://schemas.microsoft.com/office/powerpoint/2010/main" val="1832473117"/>
       </p:ext>
     </p:extLst>
   </p:cSld>
@@ -2173,7 +2197,13 @@
           <a:p>
             <a:r>
               <a:rPr lang="en-US" dirty="0"/>
-              <a:t>We’re not going to do a data modeling exercise, but will instead focus on how express CSV file semantics in SQL</a:t>
+              <a:t>Normalization is the context of an entity type, so what the entity is determines appropriateness of attributes</a:t>
+            </a:r>
+          </a:p>
+          <a:p>
+            <a:r>
+              <a:rPr lang="en-US" dirty="0"/>
+              <a:t>Naming: what is the best name for this table/entity?</a:t>
             </a:r>
           </a:p>
         </p:txBody>
@@ -2181,7 +2211,7 @@
     </p:spTree>
     <p:extLst>
       <p:ext uri="{BB962C8B-B14F-4D97-AF65-F5344CB8AC3E}">
-        <p14:creationId xmlns:p14="http://schemas.microsoft.com/office/powerpoint/2010/main" val="3605006695"/>
+        <p14:creationId xmlns:p14="http://schemas.microsoft.com/office/powerpoint/2010/main" val="4052277560"/>
       </p:ext>
     </p:extLst>
   </p:cSld>
@@ -2242,6 +2272,75 @@
           <a:p>
             <a:r>
               <a:rPr lang="en-US" dirty="0"/>
+              <a:t>We’re not going to do a data modeling exercise, but will instead focus on how express CSV file semantics in SQL</a:t>
+            </a:r>
+          </a:p>
+        </p:txBody>
+      </p:sp>
+    </p:spTree>
+    <p:extLst>
+      <p:ext uri="{BB962C8B-B14F-4D97-AF65-F5344CB8AC3E}">
+        <p14:creationId xmlns:p14="http://schemas.microsoft.com/office/powerpoint/2010/main" val="3605006695"/>
+      </p:ext>
+    </p:extLst>
+  </p:cSld>
+  <p:clrMapOvr>
+    <a:masterClrMapping/>
+  </p:clrMapOvr>
+</p:notes>
+</file>
+
+<file path=ppt/notesSlides/notesSlide28.xml><?xml version="1.0" encoding="utf-8"?>
+<p:notes xmlns:a="http://schemas.openxmlformats.org/drawingml/2006/main" xmlns:r="http://schemas.openxmlformats.org/officeDocument/2006/relationships" xmlns:p="http://schemas.openxmlformats.org/presentationml/2006/main">
+  <p:cSld>
+    <p:spTree>
+      <p:nvGrpSpPr>
+        <p:cNvPr id="1" name=""/>
+        <p:cNvGrpSpPr/>
+        <p:nvPr/>
+      </p:nvGrpSpPr>
+      <p:grpSpPr>
+        <a:xfrm>
+          <a:off x="0" y="0"/>
+          <a:ext cx="0" cy="0"/>
+          <a:chOff x="0" y="0"/>
+          <a:chExt cx="0" cy="0"/>
+        </a:xfrm>
+      </p:grpSpPr>
+      <p:sp>
+        <p:nvSpPr>
+          <p:cNvPr id="2" name="Slide Image Placeholder 1"/>
+          <p:cNvSpPr>
+            <a:spLocks noGrp="1" noRot="1" noChangeAspect="1"/>
+          </p:cNvSpPr>
+          <p:nvPr>
+            <p:ph type="sldImg"/>
+          </p:nvPr>
+        </p:nvSpPr>
+        <p:spPr>
+          <a:xfrm>
+            <a:off x="381000" y="685800"/>
+            <a:ext cx="6096000" cy="3429000"/>
+          </a:xfrm>
+        </p:spPr>
+      </p:sp>
+      <p:sp>
+        <p:nvSpPr>
+          <p:cNvPr id="3" name="Notes Placeholder 2"/>
+          <p:cNvSpPr>
+            <a:spLocks noGrp="1"/>
+          </p:cNvSpPr>
+          <p:nvPr>
+            <p:ph type="body" idx="1"/>
+          </p:nvPr>
+        </p:nvSpPr>
+        <p:spPr/>
+        <p:txBody>
+          <a:bodyPr/>
+          <a:lstStyle/>
+          <a:p>
+            <a:r>
+              <a:rPr lang="en-US" dirty="0"/>
               <a:t>View in RStudio or </a:t>
             </a:r>
             <a:r>
@@ -2265,7 +2364,7 @@
 </p:notes>
 </file>
 
-<file path=ppt/notesSlides/notesSlide28.xml><?xml version="1.0" encoding="utf-8"?>
+<file path=ppt/notesSlides/notesSlide29.xml><?xml version="1.0" encoding="utf-8"?>
 <p:notes xmlns:a="http://schemas.openxmlformats.org/drawingml/2006/main" xmlns:r="http://schemas.openxmlformats.org/officeDocument/2006/relationships" xmlns:p="http://schemas.openxmlformats.org/presentationml/2006/main">
   <p:cSld>
     <p:spTree>
@@ -17084,29 +17183,8 @@
                 <a:cs typeface="Nunito Sans"/>
                 <a:sym typeface="Nunito Sans"/>
               </a:rPr>
-              <a:t>Greg </a:t>
-            </a:r>
-            <a:r>
-              <a:rPr lang="en-US" sz="1700" dirty="0" err="1">
-                <a:solidFill>
-                  <a:srgbClr val="FFFFFF"/>
-                </a:solidFill>
-                <a:latin typeface="Nunito Sans"/>
-                <a:ea typeface="Nunito Sans"/>
-                <a:cs typeface="Nunito Sans"/>
-                <a:sym typeface="Nunito Sans"/>
-              </a:rPr>
-              <a:t>Janée</a:t>
-            </a:r>
-            <a:endParaRPr sz="1700" dirty="0">
-              <a:solidFill>
-                <a:srgbClr val="FFFFFF"/>
-              </a:solidFill>
-              <a:latin typeface="Nunito Sans"/>
-              <a:ea typeface="Nunito Sans"/>
-              <a:cs typeface="Nunito Sans"/>
-              <a:sym typeface="Nunito Sans"/>
-            </a:endParaRPr>
+              <a:t>Greg Janée</a:t>
+            </a:r>
           </a:p>
           <a:p>
             <a:pPr marL="0" lvl="0" indent="0" algn="l" rtl="0">
@@ -17119,7 +17197,7 @@
               <a:buNone/>
             </a:pPr>
             <a:r>
-              <a:rPr lang="en" sz="1300" dirty="0">
+              <a:rPr lang="en-US" sz="1300" dirty="0">
                 <a:solidFill>
                   <a:srgbClr val="FEBC11"/>
                 </a:solidFill>
@@ -17130,15 +17208,6 @@
               </a:rPr>
               <a:t>Research Data Services, UCSB Library</a:t>
             </a:r>
-            <a:endParaRPr sz="1300" dirty="0">
-              <a:solidFill>
-                <a:srgbClr val="FEBC11"/>
-              </a:solidFill>
-              <a:latin typeface="Nunito Sans"/>
-              <a:ea typeface="Nunito Sans"/>
-              <a:cs typeface="Nunito Sans"/>
-              <a:sym typeface="Nunito Sans"/>
-            </a:endParaRPr>
           </a:p>
           <a:p>
             <a:pPr marL="0" lvl="0" indent="0" algn="l" rtl="0">
@@ -17151,7 +17220,7 @@
               <a:buNone/>
             </a:pPr>
             <a:r>
-              <a:rPr lang="en" sz="1300" dirty="0" err="1">
+              <a:rPr lang="en-US" sz="1300" dirty="0" err="1">
                 <a:solidFill>
                   <a:srgbClr val="FEBC11"/>
                 </a:solidFill>
@@ -17162,7 +17231,7 @@
               </a:rPr>
               <a:t>rds@library.ucsb.edu</a:t>
             </a:r>
-            <a:endParaRPr sz="1300" dirty="0">
+            <a:endParaRPr lang="en-US" sz="1300" dirty="0">
               <a:solidFill>
                 <a:srgbClr val="FEBC11"/>
               </a:solidFill>
@@ -17325,7 +17394,7 @@
 </file>
 
 <file path=ppt/slides/slide10.xml><?xml version="1.0" encoding="utf-8"?>
-<p:sld xmlns:a="http://schemas.openxmlformats.org/drawingml/2006/main" xmlns:r="http://schemas.openxmlformats.org/officeDocument/2006/relationships" xmlns:p="http://schemas.openxmlformats.org/presentationml/2006/main">
+<p:sld xmlns:a="http://schemas.openxmlformats.org/drawingml/2006/main" xmlns:r="http://schemas.openxmlformats.org/officeDocument/2006/relationships" xmlns:p="http://schemas.openxmlformats.org/presentationml/2006/main" show="0">
   <p:cSld>
     <p:spTree>
       <p:nvGrpSpPr>
@@ -17663,7 +17732,16 @@
               <a:rPr lang="en-US" sz="1100" dirty="0">
                 <a:latin typeface="Avenir Book" panose="02000503020000020003" pitchFamily="2" charset="0"/>
               </a:rPr>
-              <a:t>Usually unique; conceptually unordered</a:t>
+              <a:t>Usually unique; </a:t>
+            </a:r>
+            <a:r>
+              <a:rPr lang="en-US" sz="1100" dirty="0">
+                <a:solidFill>
+                  <a:srgbClr val="FF0000"/>
+                </a:solidFill>
+                <a:latin typeface="Avenir Book" panose="02000503020000020003" pitchFamily="2" charset="0"/>
+              </a:rPr>
+              <a:t>conceptually unordered</a:t>
             </a:r>
           </a:p>
           <a:p>
@@ -18304,7 +18382,11 @@
           <a:lstStyle/>
           <a:p>
             <a:r>
-              <a:rPr lang="en-US" dirty="0"/>
+              <a:rPr lang="en-US" dirty="0">
+                <a:solidFill>
+                  <a:srgbClr val="FF0000"/>
+                </a:solidFill>
+              </a:rPr>
               <a:t>Strictly typed</a:t>
             </a:r>
           </a:p>
@@ -19014,7 +19096,7 @@
         <p:spPr/>
         <p:txBody>
           <a:bodyPr>
-            <a:normAutofit lnSpcReduction="10000"/>
+            <a:normAutofit fontScale="92500" lnSpcReduction="10000"/>
           </a:bodyPr>
           <a:lstStyle/>
           <a:p>
@@ -19089,7 +19171,7 @@
               <a:rPr lang="en-US" dirty="0">
                 <a:latin typeface="Avenir Book" panose="02000503020000020003" pitchFamily="2" charset="0"/>
               </a:rPr>
-              <a:t>Value constraints</a:t>
+              <a:t>Column value constraints</a:t>
             </a:r>
           </a:p>
           <a:p>
@@ -19119,7 +19201,16 @@
               <a:rPr lang="en-US" dirty="0">
                 <a:latin typeface="Avenir Book" panose="02000503020000020003" pitchFamily="2" charset="0"/>
               </a:rPr>
-              <a:t>Uniqueness</a:t>
+              <a:t>Relationships between columns</a:t>
+            </a:r>
+          </a:p>
+          <a:p>
+            <a:pPr lvl="1"/>
+            <a:r>
+              <a:rPr lang="en-US" dirty="0">
+                <a:latin typeface="Avenir Book" panose="02000503020000020003" pitchFamily="2" charset="0"/>
+              </a:rPr>
+              <a:t>Uniqueness across table</a:t>
             </a:r>
           </a:p>
           <a:p>
@@ -20548,6 +20639,48 @@
         <p:txBody>
           <a:bodyPr/>
           <a:lstStyle/>
+          <a:p>
+            <a:r>
+              <a:rPr lang="en-US" dirty="0"/>
+              <a:t>Three requirements: </a:t>
+            </a:r>
+            <a:r>
+              <a:rPr lang="en-US" dirty="0">
+                <a:solidFill>
+                  <a:srgbClr val="FF0000"/>
+                </a:solidFill>
+              </a:rPr>
+              <a:t>unique</a:t>
+            </a:r>
+            <a:r>
+              <a:rPr lang="en-US" dirty="0"/>
+              <a:t>, </a:t>
+            </a:r>
+            <a:r>
+              <a:rPr lang="en-US" dirty="0">
+                <a:solidFill>
+                  <a:srgbClr val="FF0000"/>
+                </a:solidFill>
+              </a:rPr>
+              <a:t>non-null</a:t>
+            </a:r>
+            <a:r>
+              <a:rPr lang="en-US" dirty="0"/>
+              <a:t>, </a:t>
+            </a:r>
+            <a:r>
+              <a:rPr lang="en-US" dirty="0">
+                <a:solidFill>
+                  <a:srgbClr val="FF0000"/>
+                </a:solidFill>
+              </a:rPr>
+              <a:t>unchanging</a:t>
+            </a:r>
+          </a:p>
+          <a:p>
+            <a:pPr lvl="1"/>
+            <a:endParaRPr lang="en-US" dirty="0"/>
+          </a:p>
           <a:p>
             <a:r>
               <a:rPr lang="en-US" dirty="0"/>
@@ -23422,6 +23555,323 @@
   <p:cSld>
     <p:spTree>
       <p:nvGrpSpPr>
+        <p:cNvPr id="1" name="">
+          <a:extLst>
+            <a:ext uri="{FF2B5EF4-FFF2-40B4-BE49-F238E27FC236}">
+              <a16:creationId xmlns:a16="http://schemas.microsoft.com/office/drawing/2014/main" id="{5FCB20E4-0BF7-552D-59B8-B9A3F0D6AE29}"/>
+            </a:ext>
+          </a:extLst>
+        </p:cNvPr>
+        <p:cNvGrpSpPr/>
+        <p:nvPr/>
+      </p:nvGrpSpPr>
+      <p:grpSpPr>
+        <a:xfrm>
+          <a:off x="0" y="0"/>
+          <a:ext cx="0" cy="0"/>
+          <a:chOff x="0" y="0"/>
+          <a:chExt cx="0" cy="0"/>
+        </a:xfrm>
+      </p:grpSpPr>
+      <p:sp>
+        <p:nvSpPr>
+          <p:cNvPr id="2" name="Title 1">
+            <a:extLst>
+              <a:ext uri="{FF2B5EF4-FFF2-40B4-BE49-F238E27FC236}">
+                <a16:creationId xmlns:a16="http://schemas.microsoft.com/office/drawing/2014/main" id="{E9291180-6582-8D26-4A32-7D049CE9B644}"/>
+              </a:ext>
+            </a:extLst>
+          </p:cNvPr>
+          <p:cNvSpPr>
+            <a:spLocks noGrp="1"/>
+          </p:cNvSpPr>
+          <p:nvPr>
+            <p:ph type="title"/>
+          </p:nvPr>
+        </p:nvSpPr>
+        <p:spPr/>
+        <p:txBody>
+          <a:bodyPr/>
+          <a:lstStyle/>
+          <a:p>
+            <a:r>
+              <a:rPr lang="en-US" dirty="0"/>
+              <a:t>Readings</a:t>
+            </a:r>
+          </a:p>
+        </p:txBody>
+      </p:sp>
+      <p:sp>
+        <p:nvSpPr>
+          <p:cNvPr id="3" name="Text Placeholder 2">
+            <a:extLst>
+              <a:ext uri="{FF2B5EF4-FFF2-40B4-BE49-F238E27FC236}">
+                <a16:creationId xmlns:a16="http://schemas.microsoft.com/office/drawing/2014/main" id="{6CB53B8B-E3FE-6F3D-1975-FC42CE70B062}"/>
+              </a:ext>
+            </a:extLst>
+          </p:cNvPr>
+          <p:cNvSpPr>
+            <a:spLocks noGrp="1"/>
+          </p:cNvSpPr>
+          <p:nvPr>
+            <p:ph type="body" idx="1"/>
+          </p:nvPr>
+        </p:nvSpPr>
+        <p:spPr/>
+        <p:txBody>
+          <a:bodyPr>
+            <a:normAutofit/>
+          </a:bodyPr>
+          <a:lstStyle/>
+          <a:p>
+            <a:r>
+              <a:rPr lang="en-US" dirty="0"/>
+              <a:t>NCEAS Data Modeling Essentials (15min)</a:t>
+            </a:r>
+          </a:p>
+          <a:p>
+            <a:pPr lvl="1"/>
+            <a:r>
+              <a:rPr lang="en-US" dirty="0">
+                <a:latin typeface="Avenir Book" panose="02000503020000020003" pitchFamily="2" charset="0"/>
+              </a:rPr>
+              <a:t>8.1: Tidy data</a:t>
+            </a:r>
+          </a:p>
+          <a:p>
+            <a:pPr lvl="1"/>
+            <a:r>
+              <a:rPr lang="en-US" dirty="0">
+                <a:latin typeface="Avenir Book" panose="02000503020000020003" pitchFamily="2" charset="0"/>
+              </a:rPr>
+              <a:t>8.2: Data normalization</a:t>
+            </a:r>
+          </a:p>
+          <a:p>
+            <a:pPr lvl="1"/>
+            <a:r>
+              <a:rPr lang="en-US" dirty="0">
+                <a:latin typeface="Avenir Book" panose="02000503020000020003" pitchFamily="2" charset="0"/>
+              </a:rPr>
+              <a:t>8.3: Relational data models</a:t>
+            </a:r>
+          </a:p>
+          <a:p>
+            <a:pPr lvl="1"/>
+            <a:endParaRPr lang="en-US" dirty="0">
+              <a:latin typeface="Avenir Book" panose="02000503020000020003" pitchFamily="2" charset="0"/>
+            </a:endParaRPr>
+          </a:p>
+          <a:p>
+            <a:r>
+              <a:rPr lang="en-US" dirty="0"/>
+              <a:t>Wohner 2022 (5min)</a:t>
+            </a:r>
+          </a:p>
+          <a:p>
+            <a:pPr lvl="1"/>
+            <a:r>
+              <a:rPr lang="en-US" dirty="0">
+                <a:latin typeface="Avenir Book" panose="02000503020000020003" pitchFamily="2" charset="0"/>
+              </a:rPr>
+              <a:t>2.1: Previous shortcomings of the data model</a:t>
+            </a:r>
+          </a:p>
+        </p:txBody>
+      </p:sp>
+      <p:sp>
+        <p:nvSpPr>
+          <p:cNvPr id="4" name="Slide Number Placeholder 3">
+            <a:extLst>
+              <a:ext uri="{FF2B5EF4-FFF2-40B4-BE49-F238E27FC236}">
+                <a16:creationId xmlns:a16="http://schemas.microsoft.com/office/drawing/2014/main" id="{25978255-2B0D-4EA3-04A6-4ED5123AC6DE}"/>
+              </a:ext>
+            </a:extLst>
+          </p:cNvPr>
+          <p:cNvSpPr>
+            <a:spLocks noGrp="1"/>
+          </p:cNvSpPr>
+          <p:nvPr>
+            <p:ph type="sldNum" idx="12"/>
+          </p:nvPr>
+        </p:nvSpPr>
+        <p:spPr/>
+        <p:txBody>
+          <a:bodyPr/>
+          <a:lstStyle/>
+          <a:p>
+            <a:pPr marL="0" lvl="0" indent="0" algn="r" rtl="0">
+              <a:spcBef>
+                <a:spcPts val="0"/>
+              </a:spcBef>
+              <a:spcAft>
+                <a:spcPts val="0"/>
+              </a:spcAft>
+              <a:buNone/>
+            </a:pPr>
+            <a:fld id="{00000000-1234-1234-1234-123412341234}" type="slidenum">
+              <a:rPr lang="en" smtClean="0"/>
+              <a:t>19</a:t>
+            </a:fld>
+            <a:endParaRPr lang="en" dirty="0"/>
+          </a:p>
+        </p:txBody>
+      </p:sp>
+    </p:spTree>
+    <p:extLst>
+      <p:ext uri="{BB962C8B-B14F-4D97-AF65-F5344CB8AC3E}">
+        <p14:creationId xmlns:p14="http://schemas.microsoft.com/office/powerpoint/2010/main" val="3878303054"/>
+      </p:ext>
+    </p:extLst>
+  </p:cSld>
+  <p:clrMapOvr>
+    <a:masterClrMapping/>
+  </p:clrMapOvr>
+</p:sld>
+</file>
+
+<file path=ppt/slides/slide2.xml><?xml version="1.0" encoding="utf-8"?>
+<p:sld xmlns:a="http://schemas.openxmlformats.org/drawingml/2006/main" xmlns:r="http://schemas.openxmlformats.org/officeDocument/2006/relationships" xmlns:p="http://schemas.openxmlformats.org/presentationml/2006/main">
+  <p:cSld>
+    <p:spTree>
+      <p:nvGrpSpPr>
+        <p:cNvPr id="1" name="Shape 145"/>
+        <p:cNvGrpSpPr/>
+        <p:nvPr/>
+      </p:nvGrpSpPr>
+      <p:grpSpPr>
+        <a:xfrm>
+          <a:off x="0" y="0"/>
+          <a:ext cx="0" cy="0"/>
+          <a:chOff x="0" y="0"/>
+          <a:chExt cx="0" cy="0"/>
+        </a:xfrm>
+      </p:grpSpPr>
+      <p:sp>
+        <p:nvSpPr>
+          <p:cNvPr id="5" name="Title 4">
+            <a:extLst>
+              <a:ext uri="{FF2B5EF4-FFF2-40B4-BE49-F238E27FC236}">
+                <a16:creationId xmlns:a16="http://schemas.microsoft.com/office/drawing/2014/main" id="{F1DD394F-4238-CED7-B93B-79FEC9EF9F10}"/>
+              </a:ext>
+            </a:extLst>
+          </p:cNvPr>
+          <p:cNvSpPr>
+            <a:spLocks noGrp="1"/>
+          </p:cNvSpPr>
+          <p:nvPr>
+            <p:ph type="title"/>
+          </p:nvPr>
+        </p:nvSpPr>
+        <p:spPr/>
+        <p:txBody>
+          <a:bodyPr/>
+          <a:lstStyle/>
+          <a:p>
+            <a:r>
+              <a:rPr lang="en-US" dirty="0"/>
+              <a:t>Learning objectives</a:t>
+            </a:r>
+          </a:p>
+        </p:txBody>
+      </p:sp>
+      <p:sp>
+        <p:nvSpPr>
+          <p:cNvPr id="6" name="Text Placeholder 5">
+            <a:extLst>
+              <a:ext uri="{FF2B5EF4-FFF2-40B4-BE49-F238E27FC236}">
+                <a16:creationId xmlns:a16="http://schemas.microsoft.com/office/drawing/2014/main" id="{2A92C8E0-AA8D-FED6-880C-601DDECD533B}"/>
+              </a:ext>
+            </a:extLst>
+          </p:cNvPr>
+          <p:cNvSpPr>
+            <a:spLocks noGrp="1"/>
+          </p:cNvSpPr>
+          <p:nvPr>
+            <p:ph type="body" idx="1"/>
+          </p:nvPr>
+        </p:nvSpPr>
+        <p:spPr/>
+        <p:txBody>
+          <a:bodyPr/>
+          <a:lstStyle/>
+          <a:p>
+            <a:r>
+              <a:rPr lang="en-US" dirty="0"/>
+              <a:t>Benefits of relational databases</a:t>
+            </a:r>
+          </a:p>
+          <a:p>
+            <a:r>
+              <a:rPr lang="en-US" dirty="0"/>
+              <a:t>Uses in Earth and environmental sciences</a:t>
+            </a:r>
+          </a:p>
+          <a:p>
+            <a:r>
+              <a:rPr lang="en-US" dirty="0"/>
+              <a:t>Relational data model and SQL data definition</a:t>
+            </a:r>
+          </a:p>
+          <a:p>
+            <a:r>
+              <a:rPr lang="en-US" dirty="0"/>
+              <a:t>Data modeling</a:t>
+            </a:r>
+          </a:p>
+        </p:txBody>
+      </p:sp>
+      <p:sp>
+        <p:nvSpPr>
+          <p:cNvPr id="7" name="Slide Number Placeholder 6">
+            <a:extLst>
+              <a:ext uri="{FF2B5EF4-FFF2-40B4-BE49-F238E27FC236}">
+                <a16:creationId xmlns:a16="http://schemas.microsoft.com/office/drawing/2014/main" id="{CB1183F7-8A39-501D-ED5D-4756FC7BCA23}"/>
+              </a:ext>
+            </a:extLst>
+          </p:cNvPr>
+          <p:cNvSpPr>
+            <a:spLocks noGrp="1"/>
+          </p:cNvSpPr>
+          <p:nvPr>
+            <p:ph type="sldNum" idx="12"/>
+          </p:nvPr>
+        </p:nvSpPr>
+        <p:spPr/>
+        <p:txBody>
+          <a:bodyPr/>
+          <a:lstStyle/>
+          <a:p>
+            <a:pPr marL="0" lvl="0" indent="0" algn="r" rtl="0">
+              <a:spcBef>
+                <a:spcPts val="0"/>
+              </a:spcBef>
+              <a:spcAft>
+                <a:spcPts val="0"/>
+              </a:spcAft>
+              <a:buNone/>
+            </a:pPr>
+            <a:fld id="{00000000-1234-1234-1234-123412341234}" type="slidenum">
+              <a:rPr lang="en" smtClean="0"/>
+              <a:t>2</a:t>
+            </a:fld>
+            <a:endParaRPr lang="en" dirty="0"/>
+          </a:p>
+        </p:txBody>
+      </p:sp>
+    </p:spTree>
+  </p:cSld>
+  <p:clrMapOvr>
+    <a:masterClrMapping/>
+  </p:clrMapOvr>
+</p:sld>
+</file>
+
+<file path=ppt/slides/slide20.xml><?xml version="1.0" encoding="utf-8"?>
+<p:sld xmlns:a="http://schemas.openxmlformats.org/drawingml/2006/main" xmlns:r="http://schemas.openxmlformats.org/officeDocument/2006/relationships" xmlns:p="http://schemas.openxmlformats.org/presentationml/2006/main" show="0">
+  <p:cSld>
+    <p:spTree>
+      <p:nvGrpSpPr>
         <p:cNvPr id="1" name=""/>
         <p:cNvGrpSpPr/>
         <p:nvPr/>
@@ -23519,7 +23969,7 @@
             </a:pPr>
             <a:fld id="{00000000-1234-1234-1234-123412341234}" type="slidenum">
               <a:rPr lang="en" smtClean="0"/>
-              <a:t>19</a:t>
+              <a:t>20</a:t>
             </a:fld>
             <a:endParaRPr lang="en" dirty="0"/>
           </a:p>
@@ -23616,144 +24066,7 @@
 </p:sld>
 </file>
 
-<file path=ppt/slides/slide2.xml><?xml version="1.0" encoding="utf-8"?>
-<p:sld xmlns:a="http://schemas.openxmlformats.org/drawingml/2006/main" xmlns:r="http://schemas.openxmlformats.org/officeDocument/2006/relationships" xmlns:p="http://schemas.openxmlformats.org/presentationml/2006/main">
-  <p:cSld>
-    <p:spTree>
-      <p:nvGrpSpPr>
-        <p:cNvPr id="1" name="Shape 145"/>
-        <p:cNvGrpSpPr/>
-        <p:nvPr/>
-      </p:nvGrpSpPr>
-      <p:grpSpPr>
-        <a:xfrm>
-          <a:off x="0" y="0"/>
-          <a:ext cx="0" cy="0"/>
-          <a:chOff x="0" y="0"/>
-          <a:chExt cx="0" cy="0"/>
-        </a:xfrm>
-      </p:grpSpPr>
-      <p:sp>
-        <p:nvSpPr>
-          <p:cNvPr id="5" name="Title 4">
-            <a:extLst>
-              <a:ext uri="{FF2B5EF4-FFF2-40B4-BE49-F238E27FC236}">
-                <a16:creationId xmlns:a16="http://schemas.microsoft.com/office/drawing/2014/main" id="{F1DD394F-4238-CED7-B93B-79FEC9EF9F10}"/>
-              </a:ext>
-            </a:extLst>
-          </p:cNvPr>
-          <p:cNvSpPr>
-            <a:spLocks noGrp="1"/>
-          </p:cNvSpPr>
-          <p:nvPr>
-            <p:ph type="title"/>
-          </p:nvPr>
-        </p:nvSpPr>
-        <p:spPr/>
-        <p:txBody>
-          <a:bodyPr/>
-          <a:lstStyle/>
-          <a:p>
-            <a:r>
-              <a:rPr lang="en-US" dirty="0"/>
-              <a:t>Learning objectives</a:t>
-            </a:r>
-          </a:p>
-        </p:txBody>
-      </p:sp>
-      <p:sp>
-        <p:nvSpPr>
-          <p:cNvPr id="6" name="Text Placeholder 5">
-            <a:extLst>
-              <a:ext uri="{FF2B5EF4-FFF2-40B4-BE49-F238E27FC236}">
-                <a16:creationId xmlns:a16="http://schemas.microsoft.com/office/drawing/2014/main" id="{2A92C8E0-AA8D-FED6-880C-601DDECD533B}"/>
-              </a:ext>
-            </a:extLst>
-          </p:cNvPr>
-          <p:cNvSpPr>
-            <a:spLocks noGrp="1"/>
-          </p:cNvSpPr>
-          <p:nvPr>
-            <p:ph type="body" idx="1"/>
-          </p:nvPr>
-        </p:nvSpPr>
-        <p:spPr/>
-        <p:txBody>
-          <a:bodyPr/>
-          <a:lstStyle/>
-          <a:p>
-            <a:r>
-              <a:rPr lang="en-US" dirty="0"/>
-              <a:t>Benefits of relational databases</a:t>
-            </a:r>
-          </a:p>
-          <a:p>
-            <a:r>
-              <a:rPr lang="en-US" dirty="0"/>
-              <a:t>Uses in Earth and environmental sciences</a:t>
-            </a:r>
-          </a:p>
-          <a:p>
-            <a:r>
-              <a:rPr lang="en-US" dirty="0"/>
-              <a:t>Relational data model and SQL data definition</a:t>
-            </a:r>
-          </a:p>
-          <a:p>
-            <a:r>
-              <a:rPr lang="en-US" dirty="0"/>
-              <a:t>Data modeling</a:t>
-            </a:r>
-          </a:p>
-        </p:txBody>
-      </p:sp>
-      <p:sp>
-        <p:nvSpPr>
-          <p:cNvPr id="7" name="Slide Number Placeholder 6">
-            <a:extLst>
-              <a:ext uri="{FF2B5EF4-FFF2-40B4-BE49-F238E27FC236}">
-                <a16:creationId xmlns:a16="http://schemas.microsoft.com/office/drawing/2014/main" id="{CB1183F7-8A39-501D-ED5D-4756FC7BCA23}"/>
-              </a:ext>
-            </a:extLst>
-          </p:cNvPr>
-          <p:cNvSpPr>
-            <a:spLocks noGrp="1"/>
-          </p:cNvSpPr>
-          <p:nvPr>
-            <p:ph type="sldNum" idx="12"/>
-          </p:nvPr>
-        </p:nvSpPr>
-        <p:spPr/>
-        <p:txBody>
-          <a:bodyPr/>
-          <a:lstStyle/>
-          <a:p>
-            <a:pPr marL="0" lvl="0" indent="0" algn="r" rtl="0">
-              <a:spcBef>
-                <a:spcPts val="0"/>
-              </a:spcBef>
-              <a:spcAft>
-                <a:spcPts val="0"/>
-              </a:spcAft>
-              <a:buNone/>
-            </a:pPr>
-            <a:fld id="{00000000-1234-1234-1234-123412341234}" type="slidenum">
-              <a:rPr lang="en" smtClean="0"/>
-              <a:t>2</a:t>
-            </a:fld>
-            <a:endParaRPr lang="en" dirty="0"/>
-          </a:p>
-        </p:txBody>
-      </p:sp>
-    </p:spTree>
-  </p:cSld>
-  <p:clrMapOvr>
-    <a:masterClrMapping/>
-  </p:clrMapOvr>
-</p:sld>
-</file>
-
-<file path=ppt/slides/slide20.xml><?xml version="1.0" encoding="utf-8"?>
+<file path=ppt/slides/slide21.xml><?xml version="1.0" encoding="utf-8"?>
 <p:sld xmlns:a="http://schemas.openxmlformats.org/drawingml/2006/main" xmlns:r="http://schemas.openxmlformats.org/officeDocument/2006/relationships" xmlns:p="http://schemas.openxmlformats.org/presentationml/2006/main">
   <p:cSld>
     <p:spTree>
@@ -23946,7 +24259,7 @@
             </a:pPr>
             <a:fld id="{00000000-1234-1234-1234-123412341234}" type="slidenum">
               <a:rPr lang="en" smtClean="0"/>
-              <a:t>20</a:t>
+              <a:t>21</a:t>
             </a:fld>
             <a:endParaRPr lang="en" dirty="0"/>
           </a:p>
@@ -23965,7 +24278,7 @@
 </p:sld>
 </file>
 
-<file path=ppt/slides/slide21.xml><?xml version="1.0" encoding="utf-8"?>
+<file path=ppt/slides/slide22.xml><?xml version="1.0" encoding="utf-8"?>
 <p:sld xmlns:a="http://schemas.openxmlformats.org/drawingml/2006/main" xmlns:r="http://schemas.openxmlformats.org/officeDocument/2006/relationships" xmlns:p="http://schemas.openxmlformats.org/presentationml/2006/main">
   <p:cSld>
     <p:spTree>
@@ -24076,7 +24389,7 @@
             </a:pPr>
             <a:fld id="{00000000-1234-1234-1234-123412341234}" type="slidenum">
               <a:rPr lang="en" smtClean="0"/>
-              <a:t>21</a:t>
+              <a:t>22</a:t>
             </a:fld>
             <a:endParaRPr lang="en" dirty="0"/>
           </a:p>
@@ -24992,7 +25305,7 @@
 </p:sld>
 </file>
 
-<file path=ppt/slides/slide22.xml><?xml version="1.0" encoding="utf-8"?>
+<file path=ppt/slides/slide23.xml><?xml version="1.0" encoding="utf-8"?>
 <p:sld xmlns:a="http://schemas.openxmlformats.org/drawingml/2006/main" xmlns:r="http://schemas.openxmlformats.org/officeDocument/2006/relationships" xmlns:p="http://schemas.openxmlformats.org/presentationml/2006/main">
   <p:cSld>
     <p:spTree>
@@ -25112,7 +25425,7 @@
             </a:pPr>
             <a:fld id="{00000000-1234-1234-1234-123412341234}" type="slidenum">
               <a:rPr lang="en" smtClean="0"/>
-              <a:t>22</a:t>
+              <a:t>23</a:t>
             </a:fld>
             <a:endParaRPr lang="en" dirty="0"/>
           </a:p>
@@ -26080,7 +26393,7 @@
 </p:sld>
 </file>
 
-<file path=ppt/slides/slide23.xml><?xml version="1.0" encoding="utf-8"?>
+<file path=ppt/slides/slide24.xml><?xml version="1.0" encoding="utf-8"?>
 <p:sld xmlns:a="http://schemas.openxmlformats.org/drawingml/2006/main" xmlns:r="http://schemas.openxmlformats.org/officeDocument/2006/relationships" xmlns:p="http://schemas.openxmlformats.org/presentationml/2006/main">
   <p:cSld>
     <p:spTree>
@@ -26185,7 +26498,7 @@
             </a:pPr>
             <a:fld id="{00000000-1234-1234-1234-123412341234}" type="slidenum">
               <a:rPr lang="en" smtClean="0"/>
-              <a:t>23</a:t>
+              <a:t>24</a:t>
             </a:fld>
             <a:endParaRPr lang="en" dirty="0"/>
           </a:p>
@@ -27659,196 +27972,6 @@
 </p:sld>
 </file>
 
-<file path=ppt/slides/slide24.xml><?xml version="1.0" encoding="utf-8"?>
-<p:sld xmlns:a="http://schemas.openxmlformats.org/drawingml/2006/main" xmlns:r="http://schemas.openxmlformats.org/officeDocument/2006/relationships" xmlns:p="http://schemas.openxmlformats.org/presentationml/2006/main">
-  <p:cSld>
-    <p:spTree>
-      <p:nvGrpSpPr>
-        <p:cNvPr id="1" name=""/>
-        <p:cNvGrpSpPr/>
-        <p:nvPr/>
-      </p:nvGrpSpPr>
-      <p:grpSpPr>
-        <a:xfrm>
-          <a:off x="0" y="0"/>
-          <a:ext cx="0" cy="0"/>
-          <a:chOff x="0" y="0"/>
-          <a:chExt cx="0" cy="0"/>
-        </a:xfrm>
-      </p:grpSpPr>
-      <p:sp>
-        <p:nvSpPr>
-          <p:cNvPr id="2" name="Title 1">
-            <a:extLst>
-              <a:ext uri="{FF2B5EF4-FFF2-40B4-BE49-F238E27FC236}">
-                <a16:creationId xmlns:a16="http://schemas.microsoft.com/office/drawing/2014/main" id="{3983CC3A-88D2-560B-B5EE-EC61D5A52242}"/>
-              </a:ext>
-            </a:extLst>
-          </p:cNvPr>
-          <p:cNvSpPr>
-            <a:spLocks noGrp="1"/>
-          </p:cNvSpPr>
-          <p:nvPr>
-            <p:ph type="title"/>
-          </p:nvPr>
-        </p:nvSpPr>
-        <p:spPr/>
-        <p:txBody>
-          <a:bodyPr>
-            <a:noAutofit/>
-          </a:bodyPr>
-          <a:lstStyle/>
-          <a:p>
-            <a:r>
-              <a:rPr lang="en-US" sz="3200" dirty="0">
-                <a:solidFill>
-                  <a:srgbClr val="004B83"/>
-                </a:solidFill>
-              </a:rPr>
-              <a:t>Preview of coming attractions (1)</a:t>
-            </a:r>
-          </a:p>
-        </p:txBody>
-      </p:sp>
-      <p:sp>
-        <p:nvSpPr>
-          <p:cNvPr id="3" name="Text Placeholder 2">
-            <a:extLst>
-              <a:ext uri="{FF2B5EF4-FFF2-40B4-BE49-F238E27FC236}">
-                <a16:creationId xmlns:a16="http://schemas.microsoft.com/office/drawing/2014/main" id="{F193F1C7-E077-68D2-7E2A-8BAB71A382D9}"/>
-              </a:ext>
-            </a:extLst>
-          </p:cNvPr>
-          <p:cNvSpPr>
-            <a:spLocks noGrp="1"/>
-          </p:cNvSpPr>
-          <p:nvPr>
-            <p:ph type="body" idx="1"/>
-          </p:nvPr>
-        </p:nvSpPr>
-        <p:spPr/>
-        <p:txBody>
-          <a:bodyPr/>
-          <a:lstStyle/>
-          <a:p>
-            <a:r>
-              <a:rPr lang="en-US" dirty="0">
-                <a:latin typeface="Avenir Book" panose="02000503020000020003" pitchFamily="2" charset="0"/>
-              </a:rPr>
-              <a:t>SELECT name</a:t>
-            </a:r>
-            <a:br>
-              <a:rPr lang="en-US" dirty="0">
-                <a:latin typeface="Avenir Book" panose="02000503020000020003" pitchFamily="2" charset="0"/>
-              </a:rPr>
-            </a:br>
-            <a:r>
-              <a:rPr lang="en-US" dirty="0">
-                <a:latin typeface="Avenir Book" panose="02000503020000020003" pitchFamily="2" charset="0"/>
-              </a:rPr>
-              <a:t>FROM student, enrollment, course</a:t>
-            </a:r>
-            <a:br>
-              <a:rPr lang="en-US" dirty="0">
-                <a:latin typeface="Avenir Book" panose="02000503020000020003" pitchFamily="2" charset="0"/>
-              </a:rPr>
-            </a:br>
-            <a:r>
-              <a:rPr lang="en-US" dirty="0">
-                <a:latin typeface="Avenir Book" panose="02000503020000020003" pitchFamily="2" charset="0"/>
-              </a:rPr>
-              <a:t>ON …</a:t>
-            </a:r>
-            <a:br>
-              <a:rPr lang="en-US" dirty="0">
-                <a:latin typeface="Avenir Book" panose="02000503020000020003" pitchFamily="2" charset="0"/>
-              </a:rPr>
-            </a:br>
-            <a:r>
-              <a:rPr lang="en-US" dirty="0">
-                <a:latin typeface="Avenir Book" panose="02000503020000020003" pitchFamily="2" charset="0"/>
-              </a:rPr>
-              <a:t>WHERE title = ‘Potions’;</a:t>
-            </a:r>
-          </a:p>
-        </p:txBody>
-      </p:sp>
-      <p:sp>
-        <p:nvSpPr>
-          <p:cNvPr id="5" name="Text Placeholder 4">
-            <a:extLst>
-              <a:ext uri="{FF2B5EF4-FFF2-40B4-BE49-F238E27FC236}">
-                <a16:creationId xmlns:a16="http://schemas.microsoft.com/office/drawing/2014/main" id="{2C0BF0BB-D4A5-F8CB-F94E-192EFE9AF1EC}"/>
-              </a:ext>
-            </a:extLst>
-          </p:cNvPr>
-          <p:cNvSpPr>
-            <a:spLocks noGrp="1"/>
-          </p:cNvSpPr>
-          <p:nvPr>
-            <p:ph type="body" idx="2"/>
-          </p:nvPr>
-        </p:nvSpPr>
-        <p:spPr/>
-        <p:txBody>
-          <a:bodyPr/>
-          <a:lstStyle/>
-          <a:p>
-            <a:endParaRPr lang="en-US"/>
-          </a:p>
-        </p:txBody>
-      </p:sp>
-      <p:sp>
-        <p:nvSpPr>
-          <p:cNvPr id="4" name="Slide Number Placeholder 3">
-            <a:extLst>
-              <a:ext uri="{FF2B5EF4-FFF2-40B4-BE49-F238E27FC236}">
-                <a16:creationId xmlns:a16="http://schemas.microsoft.com/office/drawing/2014/main" id="{F75D26E5-4B9C-AE7C-4F67-C282F63E900E}"/>
-              </a:ext>
-            </a:extLst>
-          </p:cNvPr>
-          <p:cNvSpPr>
-            <a:spLocks noGrp="1"/>
-          </p:cNvSpPr>
-          <p:nvPr>
-            <p:ph type="sldNum" idx="12"/>
-          </p:nvPr>
-        </p:nvSpPr>
-        <p:spPr/>
-        <p:txBody>
-          <a:bodyPr/>
-          <a:lstStyle/>
-          <a:p>
-            <a:pPr marL="0" lvl="0" indent="0" algn="r" rtl="0">
-              <a:spcBef>
-                <a:spcPts val="0"/>
-              </a:spcBef>
-              <a:spcAft>
-                <a:spcPts val="0"/>
-              </a:spcAft>
-              <a:buNone/>
-            </a:pPr>
-            <a:fld id="{00000000-1234-1234-1234-123412341234}" type="slidenum">
-              <a:rPr lang="en" smtClean="0"/>
-              <a:t>24</a:t>
-            </a:fld>
-            <a:endParaRPr lang="en" dirty="0"/>
-          </a:p>
-        </p:txBody>
-      </p:sp>
-    </p:spTree>
-    <p:extLst>
-      <p:ext uri="{BB962C8B-B14F-4D97-AF65-F5344CB8AC3E}">
-        <p14:creationId xmlns:p14="http://schemas.microsoft.com/office/powerpoint/2010/main" val="1382346294"/>
-      </p:ext>
-    </p:extLst>
-  </p:cSld>
-  <p:clrMapOvr>
-    <a:masterClrMapping/>
-  </p:clrMapOvr>
-</p:sld>
-</file>
-
 <file path=ppt/slides/slide25.xml><?xml version="1.0" encoding="utf-8"?>
 <p:sld xmlns:a="http://schemas.openxmlformats.org/drawingml/2006/main" xmlns:r="http://schemas.openxmlformats.org/officeDocument/2006/relationships" xmlns:p="http://schemas.openxmlformats.org/presentationml/2006/main">
   <p:cSld>
@@ -27895,6 +28018,196 @@
                   <a:srgbClr val="004B83"/>
                 </a:solidFill>
               </a:rPr>
+              <a:t>Preview of coming attractions (1)</a:t>
+            </a:r>
+          </a:p>
+        </p:txBody>
+      </p:sp>
+      <p:sp>
+        <p:nvSpPr>
+          <p:cNvPr id="3" name="Text Placeholder 2">
+            <a:extLst>
+              <a:ext uri="{FF2B5EF4-FFF2-40B4-BE49-F238E27FC236}">
+                <a16:creationId xmlns:a16="http://schemas.microsoft.com/office/drawing/2014/main" id="{F193F1C7-E077-68D2-7E2A-8BAB71A382D9}"/>
+              </a:ext>
+            </a:extLst>
+          </p:cNvPr>
+          <p:cNvSpPr>
+            <a:spLocks noGrp="1"/>
+          </p:cNvSpPr>
+          <p:nvPr>
+            <p:ph type="body" idx="1"/>
+          </p:nvPr>
+        </p:nvSpPr>
+        <p:spPr/>
+        <p:txBody>
+          <a:bodyPr/>
+          <a:lstStyle/>
+          <a:p>
+            <a:r>
+              <a:rPr lang="en-US" dirty="0">
+                <a:latin typeface="Avenir Book" panose="02000503020000020003" pitchFamily="2" charset="0"/>
+              </a:rPr>
+              <a:t>SELECT name</a:t>
+            </a:r>
+            <a:br>
+              <a:rPr lang="en-US" dirty="0">
+                <a:latin typeface="Avenir Book" panose="02000503020000020003" pitchFamily="2" charset="0"/>
+              </a:rPr>
+            </a:br>
+            <a:r>
+              <a:rPr lang="en-US" dirty="0">
+                <a:latin typeface="Avenir Book" panose="02000503020000020003" pitchFamily="2" charset="0"/>
+              </a:rPr>
+              <a:t>FROM student, enrollment, course</a:t>
+            </a:r>
+            <a:br>
+              <a:rPr lang="en-US" dirty="0">
+                <a:latin typeface="Avenir Book" panose="02000503020000020003" pitchFamily="2" charset="0"/>
+              </a:rPr>
+            </a:br>
+            <a:r>
+              <a:rPr lang="en-US" dirty="0">
+                <a:latin typeface="Avenir Book" panose="02000503020000020003" pitchFamily="2" charset="0"/>
+              </a:rPr>
+              <a:t>ON …</a:t>
+            </a:r>
+            <a:br>
+              <a:rPr lang="en-US" dirty="0">
+                <a:latin typeface="Avenir Book" panose="02000503020000020003" pitchFamily="2" charset="0"/>
+              </a:rPr>
+            </a:br>
+            <a:r>
+              <a:rPr lang="en-US" dirty="0">
+                <a:latin typeface="Avenir Book" panose="02000503020000020003" pitchFamily="2" charset="0"/>
+              </a:rPr>
+              <a:t>WHERE title = ‘Potions’;</a:t>
+            </a:r>
+          </a:p>
+        </p:txBody>
+      </p:sp>
+      <p:sp>
+        <p:nvSpPr>
+          <p:cNvPr id="5" name="Text Placeholder 4">
+            <a:extLst>
+              <a:ext uri="{FF2B5EF4-FFF2-40B4-BE49-F238E27FC236}">
+                <a16:creationId xmlns:a16="http://schemas.microsoft.com/office/drawing/2014/main" id="{2C0BF0BB-D4A5-F8CB-F94E-192EFE9AF1EC}"/>
+              </a:ext>
+            </a:extLst>
+          </p:cNvPr>
+          <p:cNvSpPr>
+            <a:spLocks noGrp="1"/>
+          </p:cNvSpPr>
+          <p:nvPr>
+            <p:ph type="body" idx="2"/>
+          </p:nvPr>
+        </p:nvSpPr>
+        <p:spPr/>
+        <p:txBody>
+          <a:bodyPr/>
+          <a:lstStyle/>
+          <a:p>
+            <a:endParaRPr lang="en-US"/>
+          </a:p>
+        </p:txBody>
+      </p:sp>
+      <p:sp>
+        <p:nvSpPr>
+          <p:cNvPr id="4" name="Slide Number Placeholder 3">
+            <a:extLst>
+              <a:ext uri="{FF2B5EF4-FFF2-40B4-BE49-F238E27FC236}">
+                <a16:creationId xmlns:a16="http://schemas.microsoft.com/office/drawing/2014/main" id="{F75D26E5-4B9C-AE7C-4F67-C282F63E900E}"/>
+              </a:ext>
+            </a:extLst>
+          </p:cNvPr>
+          <p:cNvSpPr>
+            <a:spLocks noGrp="1"/>
+          </p:cNvSpPr>
+          <p:nvPr>
+            <p:ph type="sldNum" idx="12"/>
+          </p:nvPr>
+        </p:nvSpPr>
+        <p:spPr/>
+        <p:txBody>
+          <a:bodyPr/>
+          <a:lstStyle/>
+          <a:p>
+            <a:pPr marL="0" lvl="0" indent="0" algn="r" rtl="0">
+              <a:spcBef>
+                <a:spcPts val="0"/>
+              </a:spcBef>
+              <a:spcAft>
+                <a:spcPts val="0"/>
+              </a:spcAft>
+              <a:buNone/>
+            </a:pPr>
+            <a:fld id="{00000000-1234-1234-1234-123412341234}" type="slidenum">
+              <a:rPr lang="en" smtClean="0"/>
+              <a:t>25</a:t>
+            </a:fld>
+            <a:endParaRPr lang="en" dirty="0"/>
+          </a:p>
+        </p:txBody>
+      </p:sp>
+    </p:spTree>
+    <p:extLst>
+      <p:ext uri="{BB962C8B-B14F-4D97-AF65-F5344CB8AC3E}">
+        <p14:creationId xmlns:p14="http://schemas.microsoft.com/office/powerpoint/2010/main" val="1382346294"/>
+      </p:ext>
+    </p:extLst>
+  </p:cSld>
+  <p:clrMapOvr>
+    <a:masterClrMapping/>
+  </p:clrMapOvr>
+</p:sld>
+</file>
+
+<file path=ppt/slides/slide26.xml><?xml version="1.0" encoding="utf-8"?>
+<p:sld xmlns:a="http://schemas.openxmlformats.org/drawingml/2006/main" xmlns:r="http://schemas.openxmlformats.org/officeDocument/2006/relationships" xmlns:p="http://schemas.openxmlformats.org/presentationml/2006/main">
+  <p:cSld>
+    <p:spTree>
+      <p:nvGrpSpPr>
+        <p:cNvPr id="1" name=""/>
+        <p:cNvGrpSpPr/>
+        <p:nvPr/>
+      </p:nvGrpSpPr>
+      <p:grpSpPr>
+        <a:xfrm>
+          <a:off x="0" y="0"/>
+          <a:ext cx="0" cy="0"/>
+          <a:chOff x="0" y="0"/>
+          <a:chExt cx="0" cy="0"/>
+        </a:xfrm>
+      </p:grpSpPr>
+      <p:sp>
+        <p:nvSpPr>
+          <p:cNvPr id="2" name="Title 1">
+            <a:extLst>
+              <a:ext uri="{FF2B5EF4-FFF2-40B4-BE49-F238E27FC236}">
+                <a16:creationId xmlns:a16="http://schemas.microsoft.com/office/drawing/2014/main" id="{3983CC3A-88D2-560B-B5EE-EC61D5A52242}"/>
+              </a:ext>
+            </a:extLst>
+          </p:cNvPr>
+          <p:cNvSpPr>
+            <a:spLocks noGrp="1"/>
+          </p:cNvSpPr>
+          <p:nvPr>
+            <p:ph type="title"/>
+          </p:nvPr>
+        </p:nvSpPr>
+        <p:spPr/>
+        <p:txBody>
+          <a:bodyPr>
+            <a:noAutofit/>
+          </a:bodyPr>
+          <a:lstStyle/>
+          <a:p>
+            <a:r>
+              <a:rPr lang="en-US" sz="3200" dirty="0">
+                <a:solidFill>
+                  <a:srgbClr val="004B83"/>
+                </a:solidFill>
+              </a:rPr>
               <a:t>Preview of coming attractions (2)</a:t>
             </a:r>
           </a:p>
@@ -28126,7 +28439,7 @@
             </a:pPr>
             <a:fld id="{00000000-1234-1234-1234-123412341234}" type="slidenum">
               <a:rPr lang="en" smtClean="0"/>
-              <a:t>25</a:t>
+              <a:t>26</a:t>
             </a:fld>
             <a:endParaRPr lang="en" dirty="0"/>
           </a:p>
@@ -28396,7 +28709,7 @@
 </p:sld>
 </file>
 
-<file path=ppt/slides/slide26.xml><?xml version="1.0" encoding="utf-8"?>
+<file path=ppt/slides/slide27.xml><?xml version="1.0" encoding="utf-8"?>
 <p:sld xmlns:a="http://schemas.openxmlformats.org/drawingml/2006/main" xmlns:r="http://schemas.openxmlformats.org/officeDocument/2006/relationships" xmlns:p="http://schemas.openxmlformats.org/presentationml/2006/main">
   <p:cSld>
     <p:spTree>
@@ -28596,7 +28909,7 @@
             </a:pPr>
             <a:fld id="{00000000-1234-1234-1234-123412341234}" type="slidenum">
               <a:rPr lang="en" smtClean="0"/>
-              <a:t>26</a:t>
+              <a:t>27</a:t>
             </a:fld>
             <a:endParaRPr lang="en" dirty="0"/>
           </a:p>
@@ -28615,7 +28928,7 @@
 </p:sld>
 </file>
 
-<file path=ppt/slides/slide27.xml><?xml version="1.0" encoding="utf-8"?>
+<file path=ppt/slides/slide28.xml><?xml version="1.0" encoding="utf-8"?>
 <p:sld xmlns:a="http://schemas.openxmlformats.org/drawingml/2006/main" xmlns:r="http://schemas.openxmlformats.org/officeDocument/2006/relationships" xmlns:p="http://schemas.openxmlformats.org/presentationml/2006/main">
   <p:cSld>
     <p:spTree>
@@ -28720,7 +29033,7 @@
             </a:pPr>
             <a:fld id="{00000000-1234-1234-1234-123412341234}" type="slidenum">
               <a:rPr lang="en" smtClean="0"/>
-              <a:t>27</a:t>
+              <a:t>28</a:t>
             </a:fld>
             <a:endParaRPr lang="en" dirty="0"/>
           </a:p>
@@ -29392,7 +29705,7 @@
 </p:sld>
 </file>
 
-<file path=ppt/slides/slide28.xml><?xml version="1.0" encoding="utf-8"?>
+<file path=ppt/slides/slide29.xml><?xml version="1.0" encoding="utf-8"?>
 <p:sld xmlns:a="http://schemas.openxmlformats.org/drawingml/2006/main" xmlns:r="http://schemas.openxmlformats.org/officeDocument/2006/relationships" xmlns:p="http://schemas.openxmlformats.org/presentationml/2006/main">
   <p:cSld>
     <p:spTree>
@@ -29527,7 +29840,7 @@
             </a:pPr>
             <a:fld id="{00000000-1234-1234-1234-123412341234}" type="slidenum">
               <a:rPr lang="en" smtClean="0"/>
-              <a:t>28</a:t>
+              <a:t>29</a:t>
             </a:fld>
             <a:endParaRPr lang="en" dirty="0"/>
           </a:p>
@@ -29546,7 +29859,187 @@
 </p:sld>
 </file>
 
-<file path=ppt/slides/slide29.xml><?xml version="1.0" encoding="utf-8"?>
+<file path=ppt/slides/slide3.xml><?xml version="1.0" encoding="utf-8"?>
+<p:sld xmlns:a="http://schemas.openxmlformats.org/drawingml/2006/main" xmlns:r="http://schemas.openxmlformats.org/officeDocument/2006/relationships" xmlns:p="http://schemas.openxmlformats.org/presentationml/2006/main">
+  <p:cSld>
+    <p:spTree>
+      <p:nvGrpSpPr>
+        <p:cNvPr id="1" name=""/>
+        <p:cNvGrpSpPr/>
+        <p:nvPr/>
+      </p:nvGrpSpPr>
+      <p:grpSpPr>
+        <a:xfrm>
+          <a:off x="0" y="0"/>
+          <a:ext cx="0" cy="0"/>
+          <a:chOff x="0" y="0"/>
+          <a:chExt cx="0" cy="0"/>
+        </a:xfrm>
+      </p:grpSpPr>
+      <p:sp>
+        <p:nvSpPr>
+          <p:cNvPr id="2" name="Title 1">
+            <a:extLst>
+              <a:ext uri="{FF2B5EF4-FFF2-40B4-BE49-F238E27FC236}">
+                <a16:creationId xmlns:a16="http://schemas.microsoft.com/office/drawing/2014/main" id="{8D26504D-2DE4-7F49-FB2C-0D8B4FF0D63B}"/>
+              </a:ext>
+            </a:extLst>
+          </p:cNvPr>
+          <p:cNvSpPr>
+            <a:spLocks noGrp="1"/>
+          </p:cNvSpPr>
+          <p:nvPr>
+            <p:ph type="title"/>
+          </p:nvPr>
+        </p:nvSpPr>
+        <p:spPr/>
+        <p:txBody>
+          <a:bodyPr/>
+          <a:lstStyle/>
+          <a:p>
+            <a:r>
+              <a:rPr lang="en-US" dirty="0"/>
+              <a:t>Relational databases, the good</a:t>
+            </a:r>
+          </a:p>
+        </p:txBody>
+      </p:sp>
+      <p:sp>
+        <p:nvSpPr>
+          <p:cNvPr id="3" name="Text Placeholder 2">
+            <a:extLst>
+              <a:ext uri="{FF2B5EF4-FFF2-40B4-BE49-F238E27FC236}">
+                <a16:creationId xmlns:a16="http://schemas.microsoft.com/office/drawing/2014/main" id="{1ABC6FBA-A79D-97A1-9EA3-D01AA68A1729}"/>
+              </a:ext>
+            </a:extLst>
+          </p:cNvPr>
+          <p:cNvSpPr>
+            <a:spLocks noGrp="1"/>
+          </p:cNvSpPr>
+          <p:nvPr>
+            <p:ph type="body" idx="1"/>
+          </p:nvPr>
+        </p:nvSpPr>
+        <p:spPr/>
+        <p:txBody>
+          <a:bodyPr>
+            <a:normAutofit/>
+          </a:bodyPr>
+          <a:lstStyle/>
+          <a:p>
+            <a:r>
+              <a:rPr lang="en-US" dirty="0"/>
+              <a:t>Fundamental form of data organization for 50 years</a:t>
+            </a:r>
+          </a:p>
+          <a:p>
+            <a:r>
+              <a:rPr lang="en-US" dirty="0"/>
+              <a:t>Remarkably stable: SQL basically unchanged for 50 years!</a:t>
+            </a:r>
+          </a:p>
+          <a:p>
+            <a:r>
+              <a:rPr lang="en-US" dirty="0"/>
+              <a:t>Mathematically rigorous basis</a:t>
+            </a:r>
+          </a:p>
+          <a:p>
+            <a:r>
+              <a:rPr lang="en-US" dirty="0"/>
+              <a:t>Open-ended query system</a:t>
+            </a:r>
+          </a:p>
+          <a:p>
+            <a:r>
+              <a:rPr lang="en-US" dirty="0"/>
+              <a:t>Support collaboration</a:t>
+            </a:r>
+          </a:p>
+          <a:p>
+            <a:r>
+              <a:rPr lang="en-US" dirty="0"/>
+              <a:t>Allow (well, require) schema definition</a:t>
+            </a:r>
+          </a:p>
+          <a:p>
+            <a:r>
+              <a:rPr lang="en-US" dirty="0"/>
+              <a:t>Correctness/consistency preserving</a:t>
+            </a:r>
+          </a:p>
+          <a:p>
+            <a:r>
+              <a:rPr lang="en-US" dirty="0"/>
+              <a:t>Support concurrency, fault tolerance, replication out of the box</a:t>
+            </a:r>
+          </a:p>
+          <a:p>
+            <a:r>
+              <a:rPr lang="en-US" dirty="0"/>
+              <a:t>Turnkey performance support</a:t>
+            </a:r>
+          </a:p>
+          <a:p>
+            <a:r>
+              <a:rPr lang="en-US" dirty="0"/>
+              <a:t>Extensions for spatial objects, large corpus text, XML, JSON, etc.</a:t>
+            </a:r>
+          </a:p>
+        </p:txBody>
+      </p:sp>
+      <p:sp>
+        <p:nvSpPr>
+          <p:cNvPr id="4" name="Slide Number Placeholder 3">
+            <a:extLst>
+              <a:ext uri="{FF2B5EF4-FFF2-40B4-BE49-F238E27FC236}">
+                <a16:creationId xmlns:a16="http://schemas.microsoft.com/office/drawing/2014/main" id="{CE684AE4-A3A1-ED77-9743-B518205902F0}"/>
+              </a:ext>
+            </a:extLst>
+          </p:cNvPr>
+          <p:cNvSpPr>
+            <a:spLocks noGrp="1"/>
+          </p:cNvSpPr>
+          <p:nvPr>
+            <p:ph type="sldNum" idx="12"/>
+          </p:nvPr>
+        </p:nvSpPr>
+        <p:spPr/>
+        <p:txBody>
+          <a:bodyPr/>
+          <a:lstStyle/>
+          <a:p>
+            <a:pPr marL="0" lvl="0" indent="0" algn="r" rtl="0">
+              <a:spcBef>
+                <a:spcPts val="0"/>
+              </a:spcBef>
+              <a:spcAft>
+                <a:spcPts val="0"/>
+              </a:spcAft>
+              <a:buNone/>
+            </a:pPr>
+            <a:fld id="{00000000-1234-1234-1234-123412341234}" type="slidenum">
+              <a:rPr lang="en" smtClean="0"/>
+              <a:t>3</a:t>
+            </a:fld>
+            <a:endParaRPr lang="en" dirty="0"/>
+          </a:p>
+        </p:txBody>
+      </p:sp>
+    </p:spTree>
+    <p:extLst>
+      <p:ext uri="{BB962C8B-B14F-4D97-AF65-F5344CB8AC3E}">
+        <p14:creationId xmlns:p14="http://schemas.microsoft.com/office/powerpoint/2010/main" val="3923724195"/>
+      </p:ext>
+    </p:extLst>
+  </p:cSld>
+  <p:clrMapOvr>
+    <a:masterClrMapping/>
+  </p:clrMapOvr>
+</p:sld>
+</file>
+
+<file path=ppt/slides/slide30.xml><?xml version="1.0" encoding="utf-8"?>
 <p:sld xmlns:a="http://schemas.openxmlformats.org/drawingml/2006/main" xmlns:r="http://schemas.openxmlformats.org/officeDocument/2006/relationships" xmlns:p="http://schemas.openxmlformats.org/presentationml/2006/main">
   <p:cSld>
     <p:spTree>
@@ -29681,7 +30174,7 @@
             </a:pPr>
             <a:fld id="{00000000-1234-1234-1234-123412341234}" type="slidenum">
               <a:rPr lang="en" smtClean="0"/>
-              <a:t>29</a:t>
+              <a:t>30</a:t>
             </a:fld>
             <a:endParaRPr lang="en" dirty="0"/>
           </a:p>
@@ -30261,193 +30754,7 @@
 </p:sld>
 </file>
 
-<file path=ppt/slides/slide3.xml><?xml version="1.0" encoding="utf-8"?>
-<p:sld xmlns:a="http://schemas.openxmlformats.org/drawingml/2006/main" xmlns:r="http://schemas.openxmlformats.org/officeDocument/2006/relationships" xmlns:p="http://schemas.openxmlformats.org/presentationml/2006/main">
-  <p:cSld>
-    <p:spTree>
-      <p:nvGrpSpPr>
-        <p:cNvPr id="1" name=""/>
-        <p:cNvGrpSpPr/>
-        <p:nvPr/>
-      </p:nvGrpSpPr>
-      <p:grpSpPr>
-        <a:xfrm>
-          <a:off x="0" y="0"/>
-          <a:ext cx="0" cy="0"/>
-          <a:chOff x="0" y="0"/>
-          <a:chExt cx="0" cy="0"/>
-        </a:xfrm>
-      </p:grpSpPr>
-      <p:sp>
-        <p:nvSpPr>
-          <p:cNvPr id="2" name="Title 1">
-            <a:extLst>
-              <a:ext uri="{FF2B5EF4-FFF2-40B4-BE49-F238E27FC236}">
-                <a16:creationId xmlns:a16="http://schemas.microsoft.com/office/drawing/2014/main" id="{8D26504D-2DE4-7F49-FB2C-0D8B4FF0D63B}"/>
-              </a:ext>
-            </a:extLst>
-          </p:cNvPr>
-          <p:cNvSpPr>
-            <a:spLocks noGrp="1"/>
-          </p:cNvSpPr>
-          <p:nvPr>
-            <p:ph type="title"/>
-          </p:nvPr>
-        </p:nvSpPr>
-        <p:spPr/>
-        <p:txBody>
-          <a:bodyPr/>
-          <a:lstStyle/>
-          <a:p>
-            <a:r>
-              <a:rPr lang="en-US" dirty="0"/>
-              <a:t>Relational databases, the good</a:t>
-            </a:r>
-          </a:p>
-        </p:txBody>
-      </p:sp>
-      <p:sp>
-        <p:nvSpPr>
-          <p:cNvPr id="3" name="Text Placeholder 2">
-            <a:extLst>
-              <a:ext uri="{FF2B5EF4-FFF2-40B4-BE49-F238E27FC236}">
-                <a16:creationId xmlns:a16="http://schemas.microsoft.com/office/drawing/2014/main" id="{1ABC6FBA-A79D-97A1-9EA3-D01AA68A1729}"/>
-              </a:ext>
-            </a:extLst>
-          </p:cNvPr>
-          <p:cNvSpPr>
-            <a:spLocks noGrp="1"/>
-          </p:cNvSpPr>
-          <p:nvPr>
-            <p:ph type="body" idx="1"/>
-          </p:nvPr>
-        </p:nvSpPr>
-        <p:spPr/>
-        <p:txBody>
-          <a:bodyPr>
-            <a:normAutofit fontScale="92500" lnSpcReduction="10000"/>
-          </a:bodyPr>
-          <a:lstStyle/>
-          <a:p>
-            <a:r>
-              <a:rPr lang="en-US" dirty="0"/>
-              <a:t>Fundamental form of data organization for 50 years</a:t>
-            </a:r>
-          </a:p>
-          <a:p>
-            <a:r>
-              <a:rPr lang="en-US" dirty="0"/>
-              <a:t>Remarkably stable: SQL basically unchanged for 50 years!</a:t>
-            </a:r>
-          </a:p>
-          <a:p>
-            <a:r>
-              <a:rPr lang="en-US" dirty="0"/>
-              <a:t>Mathematically rigorous basis</a:t>
-            </a:r>
-          </a:p>
-          <a:p>
-            <a:r>
-              <a:rPr lang="en-US" dirty="0"/>
-              <a:t>Open-ended query system</a:t>
-            </a:r>
-          </a:p>
-          <a:p>
-            <a:r>
-              <a:rPr lang="en-US" dirty="0"/>
-              <a:t>Support collaboration</a:t>
-            </a:r>
-          </a:p>
-          <a:p>
-            <a:r>
-              <a:rPr lang="en-US" dirty="0"/>
-              <a:t>Allow (well, require) schema definition</a:t>
-            </a:r>
-          </a:p>
-          <a:p>
-            <a:r>
-              <a:rPr lang="en-US" dirty="0"/>
-              <a:t>Correctness/consistency preserving</a:t>
-            </a:r>
-          </a:p>
-          <a:p>
-            <a:r>
-              <a:rPr lang="en-US" dirty="0"/>
-              <a:t>Fault tolerant, even replicated</a:t>
-            </a:r>
-          </a:p>
-          <a:p>
-            <a:r>
-              <a:rPr lang="en-US" dirty="0"/>
-              <a:t>Support concurrency out of the box</a:t>
-            </a:r>
-          </a:p>
-          <a:p>
-            <a:r>
-              <a:rPr lang="en-US" dirty="0"/>
-              <a:t>Turnkey performance support</a:t>
-            </a:r>
-          </a:p>
-          <a:p>
-            <a:r>
-              <a:rPr lang="en-US" dirty="0"/>
-              <a:t>Extensions for spatial objects, large corpus text, XML, JSON, etc.</a:t>
-            </a:r>
-          </a:p>
-        </p:txBody>
-      </p:sp>
-      <p:sp>
-        <p:nvSpPr>
-          <p:cNvPr id="4" name="Slide Number Placeholder 3">
-            <a:extLst>
-              <a:ext uri="{FF2B5EF4-FFF2-40B4-BE49-F238E27FC236}">
-                <a16:creationId xmlns:a16="http://schemas.microsoft.com/office/drawing/2014/main" id="{CE684AE4-A3A1-ED77-9743-B518205902F0}"/>
-              </a:ext>
-            </a:extLst>
-          </p:cNvPr>
-          <p:cNvSpPr>
-            <a:spLocks noGrp="1"/>
-          </p:cNvSpPr>
-          <p:nvPr>
-            <p:ph type="sldNum" idx="12"/>
-          </p:nvPr>
-        </p:nvSpPr>
-        <p:spPr/>
-        <p:txBody>
-          <a:bodyPr/>
-          <a:lstStyle/>
-          <a:p>
-            <a:pPr marL="0" lvl="0" indent="0" algn="r" rtl="0">
-              <a:spcBef>
-                <a:spcPts val="0"/>
-              </a:spcBef>
-              <a:spcAft>
-                <a:spcPts val="0"/>
-              </a:spcAft>
-              <a:buNone/>
-            </a:pPr>
-            <a:fld id="{00000000-1234-1234-1234-123412341234}" type="slidenum">
-              <a:rPr lang="en" smtClean="0"/>
-              <a:t>3</a:t>
-            </a:fld>
-            <a:endParaRPr lang="en" dirty="0"/>
-          </a:p>
-        </p:txBody>
-      </p:sp>
-    </p:spTree>
-    <p:extLst>
-      <p:ext uri="{BB962C8B-B14F-4D97-AF65-F5344CB8AC3E}">
-        <p14:creationId xmlns:p14="http://schemas.microsoft.com/office/powerpoint/2010/main" val="3923724195"/>
-      </p:ext>
-    </p:extLst>
-  </p:cSld>
-  <p:clrMapOvr>
-    <a:masterClrMapping/>
-  </p:clrMapOvr>
-</p:sld>
-</file>
-
-<file path=ppt/slides/slide30.xml><?xml version="1.0" encoding="utf-8"?>
+<file path=ppt/slides/slide31.xml><?xml version="1.0" encoding="utf-8"?>
 <p:sld xmlns:a="http://schemas.openxmlformats.org/drawingml/2006/main" xmlns:r="http://schemas.openxmlformats.org/officeDocument/2006/relationships" xmlns:p="http://schemas.openxmlformats.org/presentationml/2006/main">
   <p:cSld>
     <p:spTree>
@@ -30552,7 +30859,7 @@
             </a:pPr>
             <a:fld id="{00000000-1234-1234-1234-123412341234}" type="slidenum">
               <a:rPr lang="en" smtClean="0"/>
-              <a:t>30</a:t>
+              <a:t>31</a:t>
             </a:fld>
             <a:endParaRPr lang="en" dirty="0"/>
           </a:p>
@@ -31343,7 +31650,7 @@
 </p:sld>
 </file>
 
-<file path=ppt/slides/slide31.xml><?xml version="1.0" encoding="utf-8"?>
+<file path=ppt/slides/slide32.xml><?xml version="1.0" encoding="utf-8"?>
 <p:sld xmlns:a="http://schemas.openxmlformats.org/drawingml/2006/main" xmlns:r="http://schemas.openxmlformats.org/officeDocument/2006/relationships" xmlns:p="http://schemas.openxmlformats.org/presentationml/2006/main">
   <p:cSld>
     <p:spTree>
@@ -31463,7 +31770,7 @@
             </a:pPr>
             <a:fld id="{00000000-1234-1234-1234-123412341234}" type="slidenum">
               <a:rPr lang="en" smtClean="0"/>
-              <a:t>31</a:t>
+              <a:t>32</a:t>
             </a:fld>
             <a:endParaRPr lang="en" dirty="0"/>
           </a:p>
@@ -31894,7 +32201,7 @@
 </p:sld>
 </file>
 
-<file path=ppt/slides/slide32.xml><?xml version="1.0" encoding="utf-8"?>
+<file path=ppt/slides/slide33.xml><?xml version="1.0" encoding="utf-8"?>
 <p:sld xmlns:a="http://schemas.openxmlformats.org/drawingml/2006/main" xmlns:r="http://schemas.openxmlformats.org/officeDocument/2006/relationships" xmlns:p="http://schemas.openxmlformats.org/presentationml/2006/main">
   <p:cSld>
     <p:spTree>
@@ -32002,7 +32309,7 @@
             </a:pPr>
             <a:fld id="{00000000-1234-1234-1234-123412341234}" type="slidenum">
               <a:rPr lang="en" smtClean="0"/>
-              <a:t>32</a:t>
+              <a:t>33</a:t>
             </a:fld>
             <a:endParaRPr lang="en" dirty="0"/>
           </a:p>
@@ -32509,7 +32816,7 @@
 </p:sld>
 </file>
 
-<file path=ppt/slides/slide33.xml><?xml version="1.0" encoding="utf-8"?>
+<file path=ppt/slides/slide34.xml><?xml version="1.0" encoding="utf-8"?>
 <p:sld xmlns:a="http://schemas.openxmlformats.org/drawingml/2006/main" xmlns:r="http://schemas.openxmlformats.org/officeDocument/2006/relationships" xmlns:p="http://schemas.openxmlformats.org/presentationml/2006/main">
   <p:cSld>
     <p:spTree>
@@ -32724,7 +33031,7 @@
             </a:pPr>
             <a:fld id="{00000000-1234-1234-1234-123412341234}" type="slidenum">
               <a:rPr lang="en" smtClean="0"/>
-              <a:t>33</a:t>
+              <a:t>34</a:t>
             </a:fld>
             <a:endParaRPr lang="en" dirty="0"/>
           </a:p>
@@ -32743,7 +33050,7 @@
 </p:sld>
 </file>
 
-<file path=ppt/slides/slide34.xml><?xml version="1.0" encoding="utf-8"?>
+<file path=ppt/slides/slide35.xml><?xml version="1.0" encoding="utf-8"?>
 <p:sld xmlns:a="http://schemas.openxmlformats.org/drawingml/2006/main" xmlns:r="http://schemas.openxmlformats.org/officeDocument/2006/relationships" xmlns:p="http://schemas.openxmlformats.org/presentationml/2006/main">
   <p:cSld>
     <p:spTree>
@@ -32866,7 +33173,7 @@
             </a:pPr>
             <a:fld id="{00000000-1234-1234-1234-123412341234}" type="slidenum">
               <a:rPr lang="en" smtClean="0"/>
-              <a:t>34</a:t>
+              <a:t>35</a:t>
             </a:fld>
             <a:endParaRPr lang="en" dirty="0"/>
           </a:p>
@@ -32943,7 +33250,7 @@
 </p:sld>
 </file>
 
-<file path=ppt/slides/slide35.xml><?xml version="1.0" encoding="utf-8"?>
+<file path=ppt/slides/slide36.xml><?xml version="1.0" encoding="utf-8"?>
 <p:sld xmlns:a="http://schemas.openxmlformats.org/drawingml/2006/main" xmlns:r="http://schemas.openxmlformats.org/officeDocument/2006/relationships" xmlns:p="http://schemas.openxmlformats.org/presentationml/2006/main">
   <p:cSld>
     <p:spTree>
@@ -33177,7 +33484,7 @@
             </a:pPr>
             <a:fld id="{00000000-1234-1234-1234-123412341234}" type="slidenum">
               <a:rPr lang="en" smtClean="0"/>
-              <a:t>35</a:t>
+              <a:t>36</a:t>
             </a:fld>
             <a:endParaRPr lang="en" dirty="0"/>
           </a:p>
@@ -33196,7 +33503,7 @@
 </p:sld>
 </file>
 
-<file path=ppt/slides/slide36.xml><?xml version="1.0" encoding="utf-8"?>
+<file path=ppt/slides/slide37.xml><?xml version="1.0" encoding="utf-8"?>
 <p:sld xmlns:a="http://schemas.openxmlformats.org/drawingml/2006/main" xmlns:r="http://schemas.openxmlformats.org/officeDocument/2006/relationships" xmlns:p="http://schemas.openxmlformats.org/presentationml/2006/main">
   <p:cSld>
     <p:spTree>
@@ -33337,7 +33644,7 @@
             </a:pPr>
             <a:fld id="{00000000-1234-1234-1234-123412341234}" type="slidenum">
               <a:rPr lang="en" smtClean="0"/>
-              <a:t>36</a:t>
+              <a:t>37</a:t>
             </a:fld>
             <a:endParaRPr lang="en" dirty="0"/>
           </a:p>
@@ -33356,7 +33663,7 @@
 </p:sld>
 </file>
 
-<file path=ppt/slides/slide37.xml><?xml version="1.0" encoding="utf-8"?>
+<file path=ppt/slides/slide38.xml><?xml version="1.0" encoding="utf-8"?>
 <p:sld xmlns:a="http://schemas.openxmlformats.org/drawingml/2006/main" xmlns:r="http://schemas.openxmlformats.org/officeDocument/2006/relationships" xmlns:p="http://schemas.openxmlformats.org/presentationml/2006/main">
   <p:cSld>
     <p:spTree>
@@ -33483,7 +33790,7 @@
               <a:rPr lang="en" smtClean="0">
                 <a:latin typeface="Avenir Book" panose="02000503020000020003" pitchFamily="2" charset="0"/>
               </a:rPr>
-              <a:t>37</a:t>
+              <a:t>38</a:t>
             </a:fld>
             <a:endParaRPr lang="en" dirty="0">
               <a:latin typeface="Avenir Book" panose="02000503020000020003" pitchFamily="2" charset="0"/>
@@ -33504,7 +33811,7 @@
 </p:sld>
 </file>
 
-<file path=ppt/slides/slide38.xml><?xml version="1.0" encoding="utf-8"?>
+<file path=ppt/slides/slide39.xml><?xml version="1.0" encoding="utf-8"?>
 <p:sld xmlns:a="http://schemas.openxmlformats.org/drawingml/2006/main" xmlns:r="http://schemas.openxmlformats.org/officeDocument/2006/relationships" xmlns:p="http://schemas.openxmlformats.org/presentationml/2006/main">
   <p:cSld>
     <p:spTree>
@@ -33705,7 +34012,7 @@
             </a:pPr>
             <a:fld id="{00000000-1234-1234-1234-123412341234}" type="slidenum">
               <a:rPr lang="en" smtClean="0"/>
-              <a:t>38</a:t>
+              <a:t>39</a:t>
             </a:fld>
             <a:endParaRPr lang="en" dirty="0"/>
           </a:p>
@@ -33715,449 +34022,6 @@
     <p:extLst>
       <p:ext uri="{BB962C8B-B14F-4D97-AF65-F5344CB8AC3E}">
         <p14:creationId xmlns:p14="http://schemas.microsoft.com/office/powerpoint/2010/main" val="1988830216"/>
-      </p:ext>
-    </p:extLst>
-  </p:cSld>
-  <p:clrMapOvr>
-    <a:masterClrMapping/>
-  </p:clrMapOvr>
-</p:sld>
-</file>
-
-<file path=ppt/slides/slide39.xml><?xml version="1.0" encoding="utf-8"?>
-<p:sld xmlns:a="http://schemas.openxmlformats.org/drawingml/2006/main" xmlns:r="http://schemas.openxmlformats.org/officeDocument/2006/relationships" xmlns:p="http://schemas.openxmlformats.org/presentationml/2006/main">
-  <p:cSld>
-    <p:spTree>
-      <p:nvGrpSpPr>
-        <p:cNvPr id="1" name=""/>
-        <p:cNvGrpSpPr/>
-        <p:nvPr/>
-      </p:nvGrpSpPr>
-      <p:grpSpPr>
-        <a:xfrm>
-          <a:off x="0" y="0"/>
-          <a:ext cx="0" cy="0"/>
-          <a:chOff x="0" y="0"/>
-          <a:chExt cx="0" cy="0"/>
-        </a:xfrm>
-      </p:grpSpPr>
-      <p:sp>
-        <p:nvSpPr>
-          <p:cNvPr id="2" name="Title 1">
-            <a:extLst>
-              <a:ext uri="{FF2B5EF4-FFF2-40B4-BE49-F238E27FC236}">
-                <a16:creationId xmlns:a16="http://schemas.microsoft.com/office/drawing/2014/main" id="{82AE8044-E548-A28A-F822-840354C3EDA2}"/>
-              </a:ext>
-            </a:extLst>
-          </p:cNvPr>
-          <p:cNvSpPr>
-            <a:spLocks noGrp="1"/>
-          </p:cNvSpPr>
-          <p:nvPr>
-            <p:ph type="title"/>
-          </p:nvPr>
-        </p:nvSpPr>
-        <p:spPr/>
-        <p:txBody>
-          <a:bodyPr/>
-          <a:lstStyle/>
-          <a:p>
-            <a:r>
-              <a:rPr lang="en-US" dirty="0"/>
-              <a:t>Sample table: Site</a:t>
-            </a:r>
-          </a:p>
-        </p:txBody>
-      </p:sp>
-      <p:sp>
-        <p:nvSpPr>
-          <p:cNvPr id="3" name="Text Placeholder 2">
-            <a:extLst>
-              <a:ext uri="{FF2B5EF4-FFF2-40B4-BE49-F238E27FC236}">
-                <a16:creationId xmlns:a16="http://schemas.microsoft.com/office/drawing/2014/main" id="{F01855C6-2F79-74CE-4597-783180FA08E2}"/>
-              </a:ext>
-            </a:extLst>
-          </p:cNvPr>
-          <p:cNvSpPr>
-            <a:spLocks noGrp="1"/>
-          </p:cNvSpPr>
-          <p:nvPr>
-            <p:ph type="body" idx="1"/>
-          </p:nvPr>
-        </p:nvSpPr>
-        <p:spPr/>
-        <p:txBody>
-          <a:bodyPr>
-            <a:normAutofit fontScale="62500" lnSpcReduction="20000"/>
-          </a:bodyPr>
-          <a:lstStyle/>
-          <a:p>
-            <a:r>
-              <a:rPr lang="en-US" dirty="0"/>
-              <a:t>“ASDN field sites are referred to by 4-letter codes in each of the data files”</a:t>
-            </a:r>
-          </a:p>
-          <a:p>
-            <a:pPr lvl="1"/>
-            <a:endParaRPr lang="en-US" dirty="0">
-              <a:latin typeface="Avenir Book" panose="02000503020000020003" pitchFamily="2" charset="0"/>
-            </a:endParaRPr>
-          </a:p>
-          <a:p>
-            <a:r>
-              <a:rPr lang="en-US" dirty="0">
-                <a:latin typeface="Courier New" panose="02070309020205020404" pitchFamily="49" charset="0"/>
-                <a:cs typeface="Courier New" panose="02070309020205020404" pitchFamily="49" charset="0"/>
-              </a:rPr>
-              <a:t>import pandas as pd</a:t>
-            </a:r>
-            <a:br>
-              <a:rPr lang="en-US" dirty="0">
-                <a:latin typeface="Courier New" panose="02070309020205020404" pitchFamily="49" charset="0"/>
-                <a:cs typeface="Courier New" panose="02070309020205020404" pitchFamily="49" charset="0"/>
-              </a:rPr>
-            </a:br>
-            <a:r>
-              <a:rPr lang="en-US" dirty="0" err="1">
-                <a:latin typeface="Courier New" panose="02070309020205020404" pitchFamily="49" charset="0"/>
-                <a:cs typeface="Courier New" panose="02070309020205020404" pitchFamily="49" charset="0"/>
-              </a:rPr>
-              <a:t>df</a:t>
-            </a:r>
-            <a:r>
-              <a:rPr lang="en-US" dirty="0">
-                <a:latin typeface="Courier New" panose="02070309020205020404" pitchFamily="49" charset="0"/>
-                <a:cs typeface="Courier New" panose="02070309020205020404" pitchFamily="49" charset="0"/>
-              </a:rPr>
-              <a:t> = </a:t>
-            </a:r>
-            <a:r>
-              <a:rPr lang="en-US" dirty="0" err="1">
-                <a:latin typeface="Courier New" panose="02070309020205020404" pitchFamily="49" charset="0"/>
-                <a:cs typeface="Courier New" panose="02070309020205020404" pitchFamily="49" charset="0"/>
-              </a:rPr>
-              <a:t>pd.read_csv</a:t>
-            </a:r>
-            <a:r>
-              <a:rPr lang="en-US" dirty="0">
-                <a:latin typeface="Courier New" panose="02070309020205020404" pitchFamily="49" charset="0"/>
-                <a:cs typeface="Courier New" panose="02070309020205020404" pitchFamily="49" charset="0"/>
-              </a:rPr>
-              <a:t>("</a:t>
-            </a:r>
-            <a:r>
-              <a:rPr lang="en-US" dirty="0" err="1">
-                <a:latin typeface="Courier New" panose="02070309020205020404" pitchFamily="49" charset="0"/>
-                <a:cs typeface="Courier New" panose="02070309020205020404" pitchFamily="49" charset="0"/>
-              </a:rPr>
-              <a:t>site.csv</a:t>
-            </a:r>
-            <a:r>
-              <a:rPr lang="en-US" dirty="0">
-                <a:latin typeface="Courier New" panose="02070309020205020404" pitchFamily="49" charset="0"/>
-                <a:cs typeface="Courier New" panose="02070309020205020404" pitchFamily="49" charset="0"/>
-              </a:rPr>
-              <a:t>")</a:t>
-            </a:r>
-            <a:br>
-              <a:rPr lang="en-US" dirty="0">
-                <a:latin typeface="Courier New" panose="02070309020205020404" pitchFamily="49" charset="0"/>
-                <a:cs typeface="Courier New" panose="02070309020205020404" pitchFamily="49" charset="0"/>
-              </a:rPr>
-            </a:br>
-            <a:r>
-              <a:rPr lang="en-US" dirty="0" err="1">
-                <a:latin typeface="Courier New" panose="02070309020205020404" pitchFamily="49" charset="0"/>
-                <a:cs typeface="Courier New" panose="02070309020205020404" pitchFamily="49" charset="0"/>
-              </a:rPr>
-              <a:t>df.info</a:t>
-            </a:r>
-            <a:r>
-              <a:rPr lang="en-US" dirty="0">
-                <a:latin typeface="Courier New" panose="02070309020205020404" pitchFamily="49" charset="0"/>
-                <a:cs typeface="Courier New" panose="02070309020205020404" pitchFamily="49" charset="0"/>
-              </a:rPr>
-              <a:t>()</a:t>
-            </a:r>
-          </a:p>
-          <a:p>
-            <a:pPr lvl="1"/>
-            <a:endParaRPr lang="en-US" dirty="0">
-              <a:latin typeface="Avenir Book" panose="02000503020000020003" pitchFamily="2" charset="0"/>
-            </a:endParaRPr>
-          </a:p>
-          <a:p>
-            <a:r>
-              <a:rPr lang="en-US" dirty="0"/>
-              <a:t>➜ </a:t>
-            </a:r>
-            <a:r>
-              <a:rPr lang="en-US" dirty="0">
-                <a:latin typeface="Courier New" panose="02070309020205020404" pitchFamily="49" charset="0"/>
-                <a:cs typeface="Courier New" panose="02070309020205020404" pitchFamily="49" charset="0"/>
-              </a:rPr>
-              <a:t>Data columns (total 6 columns):</a:t>
-            </a:r>
-            <a:br>
-              <a:rPr lang="en-US" dirty="0">
-                <a:latin typeface="Courier New" panose="02070309020205020404" pitchFamily="49" charset="0"/>
-                <a:cs typeface="Courier New" panose="02070309020205020404" pitchFamily="49" charset="0"/>
-              </a:rPr>
-            </a:br>
-            <a:r>
-              <a:rPr lang="en-US" dirty="0">
-                <a:latin typeface="Courier New" panose="02070309020205020404" pitchFamily="49" charset="0"/>
-                <a:cs typeface="Courier New" panose="02070309020205020404" pitchFamily="49" charset="0"/>
-              </a:rPr>
-              <a:t> #   Column                      Non-Null Count  </a:t>
-            </a:r>
-            <a:r>
-              <a:rPr lang="en-US" dirty="0" err="1">
-                <a:latin typeface="Courier New" panose="02070309020205020404" pitchFamily="49" charset="0"/>
-                <a:cs typeface="Courier New" panose="02070309020205020404" pitchFamily="49" charset="0"/>
-              </a:rPr>
-              <a:t>Dtype</a:t>
-            </a:r>
-            <a:r>
-              <a:rPr lang="en-US" dirty="0">
-                <a:latin typeface="Courier New" panose="02070309020205020404" pitchFamily="49" charset="0"/>
-                <a:cs typeface="Courier New" panose="02070309020205020404" pitchFamily="49" charset="0"/>
-              </a:rPr>
-              <a:t>  </a:t>
-            </a:r>
-            <a:br>
-              <a:rPr lang="en-US" dirty="0">
-                <a:latin typeface="Courier New" panose="02070309020205020404" pitchFamily="49" charset="0"/>
-                <a:cs typeface="Courier New" panose="02070309020205020404" pitchFamily="49" charset="0"/>
-              </a:rPr>
-            </a:br>
-            <a:r>
-              <a:rPr lang="en-US" dirty="0">
-                <a:latin typeface="Courier New" panose="02070309020205020404" pitchFamily="49" charset="0"/>
-                <a:cs typeface="Courier New" panose="02070309020205020404" pitchFamily="49" charset="0"/>
-              </a:rPr>
-              <a:t>---  ------                      --------------  -----  </a:t>
-            </a:r>
-            <a:br>
-              <a:rPr lang="en-US" dirty="0">
-                <a:latin typeface="Courier New" panose="02070309020205020404" pitchFamily="49" charset="0"/>
-                <a:cs typeface="Courier New" panose="02070309020205020404" pitchFamily="49" charset="0"/>
-              </a:rPr>
-            </a:br>
-            <a:r>
-              <a:rPr lang="en-US" dirty="0">
-                <a:latin typeface="Courier New" panose="02070309020205020404" pitchFamily="49" charset="0"/>
-                <a:cs typeface="Courier New" panose="02070309020205020404" pitchFamily="49" charset="0"/>
-              </a:rPr>
-              <a:t> 0   Code                        16 non-null     object </a:t>
-            </a:r>
-            <a:br>
-              <a:rPr lang="en-US" dirty="0">
-                <a:latin typeface="Courier New" panose="02070309020205020404" pitchFamily="49" charset="0"/>
-                <a:cs typeface="Courier New" panose="02070309020205020404" pitchFamily="49" charset="0"/>
-              </a:rPr>
-            </a:br>
-            <a:r>
-              <a:rPr lang="en-US" dirty="0">
-                <a:latin typeface="Courier New" panose="02070309020205020404" pitchFamily="49" charset="0"/>
-                <a:cs typeface="Courier New" panose="02070309020205020404" pitchFamily="49" charset="0"/>
-              </a:rPr>
-              <a:t> 1   Site name                   16 non-null     object </a:t>
-            </a:r>
-            <a:br>
-              <a:rPr lang="en-US" dirty="0">
-                <a:latin typeface="Courier New" panose="02070309020205020404" pitchFamily="49" charset="0"/>
-                <a:cs typeface="Courier New" panose="02070309020205020404" pitchFamily="49" charset="0"/>
-              </a:rPr>
-            </a:br>
-            <a:r>
-              <a:rPr lang="en-US" dirty="0">
-                <a:latin typeface="Courier New" panose="02070309020205020404" pitchFamily="49" charset="0"/>
-                <a:cs typeface="Courier New" panose="02070309020205020404" pitchFamily="49" charset="0"/>
-              </a:rPr>
-              <a:t> 2   Location                    16 non-null     object </a:t>
-            </a:r>
-            <a:br>
-              <a:rPr lang="en-US" dirty="0">
-                <a:latin typeface="Courier New" panose="02070309020205020404" pitchFamily="49" charset="0"/>
-                <a:cs typeface="Courier New" panose="02070309020205020404" pitchFamily="49" charset="0"/>
-              </a:rPr>
-            </a:br>
-            <a:r>
-              <a:rPr lang="en-US" dirty="0">
-                <a:latin typeface="Courier New" panose="02070309020205020404" pitchFamily="49" charset="0"/>
-                <a:cs typeface="Courier New" panose="02070309020205020404" pitchFamily="49" charset="0"/>
-              </a:rPr>
-              <a:t> 3   Latitude                    16 non-null     float64</a:t>
-            </a:r>
-            <a:br>
-              <a:rPr lang="en-US" dirty="0">
-                <a:latin typeface="Courier New" panose="02070309020205020404" pitchFamily="49" charset="0"/>
-                <a:cs typeface="Courier New" panose="02070309020205020404" pitchFamily="49" charset="0"/>
-              </a:rPr>
-            </a:br>
-            <a:r>
-              <a:rPr lang="en-US" dirty="0">
-                <a:latin typeface="Courier New" panose="02070309020205020404" pitchFamily="49" charset="0"/>
-                <a:cs typeface="Courier New" panose="02070309020205020404" pitchFamily="49" charset="0"/>
-              </a:rPr>
-              <a:t> 4   Longitude                   16 non-null     float64</a:t>
-            </a:r>
-            <a:br>
-              <a:rPr lang="en-US" dirty="0">
-                <a:latin typeface="Courier New" panose="02070309020205020404" pitchFamily="49" charset="0"/>
-                <a:cs typeface="Courier New" panose="02070309020205020404" pitchFamily="49" charset="0"/>
-              </a:rPr>
-            </a:br>
-            <a:r>
-              <a:rPr lang="en-US" dirty="0">
-                <a:latin typeface="Courier New" panose="02070309020205020404" pitchFamily="49" charset="0"/>
-                <a:cs typeface="Courier New" panose="02070309020205020404" pitchFamily="49" charset="0"/>
-              </a:rPr>
-              <a:t> 5   </a:t>
-            </a:r>
-            <a:r>
-              <a:rPr lang="en-US" dirty="0" err="1">
-                <a:latin typeface="Courier New" panose="02070309020205020404" pitchFamily="49" charset="0"/>
-                <a:cs typeface="Courier New" panose="02070309020205020404" pitchFamily="49" charset="0"/>
-              </a:rPr>
-              <a:t>Total_Study_Plot_Area</a:t>
-            </a:r>
-            <a:r>
-              <a:rPr lang="en-US" dirty="0">
-                <a:latin typeface="Courier New" panose="02070309020205020404" pitchFamily="49" charset="0"/>
-                <a:cs typeface="Courier New" panose="02070309020205020404" pitchFamily="49" charset="0"/>
-              </a:rPr>
-              <a:t>_(ha)  16 non-null     float64</a:t>
-            </a:r>
-          </a:p>
-          <a:p>
-            <a:pPr lvl="1"/>
-            <a:endParaRPr lang="en-US" dirty="0">
-              <a:latin typeface="Avenir Book" panose="02000503020000020003" pitchFamily="2" charset="0"/>
-            </a:endParaRPr>
-          </a:p>
-          <a:p>
-            <a:r>
-              <a:rPr lang="en-US" dirty="0" err="1">
-                <a:latin typeface="Courier New" panose="02070309020205020404" pitchFamily="49" charset="0"/>
-                <a:cs typeface="Courier New" panose="02070309020205020404" pitchFamily="49" charset="0"/>
-              </a:rPr>
-              <a:t>len</a:t>
-            </a:r>
-            <a:r>
-              <a:rPr lang="en-US" dirty="0">
-                <a:latin typeface="Courier New" panose="02070309020205020404" pitchFamily="49" charset="0"/>
-                <a:cs typeface="Courier New" panose="02070309020205020404" pitchFamily="49" charset="0"/>
-              </a:rPr>
-              <a:t>(</a:t>
-            </a:r>
-            <a:r>
-              <a:rPr lang="en-US" dirty="0" err="1">
-                <a:latin typeface="Courier New" panose="02070309020205020404" pitchFamily="49" charset="0"/>
-                <a:cs typeface="Courier New" panose="02070309020205020404" pitchFamily="49" charset="0"/>
-              </a:rPr>
-              <a:t>df.Code.unique</a:t>
-            </a:r>
-            <a:r>
-              <a:rPr lang="en-US" dirty="0">
-                <a:latin typeface="Courier New" panose="02070309020205020404" pitchFamily="49" charset="0"/>
-                <a:cs typeface="Courier New" panose="02070309020205020404" pitchFamily="49" charset="0"/>
-              </a:rPr>
-              <a:t>()), </a:t>
-            </a:r>
-            <a:r>
-              <a:rPr lang="en-US" dirty="0" err="1">
-                <a:latin typeface="Courier New" panose="02070309020205020404" pitchFamily="49" charset="0"/>
-                <a:cs typeface="Courier New" panose="02070309020205020404" pitchFamily="49" charset="0"/>
-              </a:rPr>
-              <a:t>len</a:t>
-            </a:r>
-            <a:r>
-              <a:rPr lang="en-US" dirty="0">
-                <a:latin typeface="Courier New" panose="02070309020205020404" pitchFamily="49" charset="0"/>
-                <a:cs typeface="Courier New" panose="02070309020205020404" pitchFamily="49" charset="0"/>
-              </a:rPr>
-              <a:t>(</a:t>
-            </a:r>
-            <a:r>
-              <a:rPr lang="en-US" dirty="0" err="1">
-                <a:latin typeface="Courier New" panose="02070309020205020404" pitchFamily="49" charset="0"/>
-                <a:cs typeface="Courier New" panose="02070309020205020404" pitchFamily="49" charset="0"/>
-              </a:rPr>
-              <a:t>df</a:t>
-            </a:r>
-            <a:r>
-              <a:rPr lang="en-US" dirty="0">
-                <a:latin typeface="Courier New" panose="02070309020205020404" pitchFamily="49" charset="0"/>
-                <a:cs typeface="Courier New" panose="02070309020205020404" pitchFamily="49" charset="0"/>
-              </a:rPr>
-              <a:t>["Site name"].unique())</a:t>
-            </a:r>
-          </a:p>
-          <a:p>
-            <a:pPr lvl="1"/>
-            <a:endParaRPr lang="en-US" dirty="0">
-              <a:latin typeface="Avenir Book" panose="02000503020000020003" pitchFamily="2" charset="0"/>
-            </a:endParaRPr>
-          </a:p>
-          <a:p>
-            <a:r>
-              <a:rPr lang="en-US" dirty="0"/>
-              <a:t>➜ </a:t>
-            </a:r>
-            <a:r>
-              <a:rPr lang="en-US" dirty="0">
-                <a:latin typeface="Courier New" panose="02070309020205020404" pitchFamily="49" charset="0"/>
-                <a:cs typeface="Courier New" panose="02070309020205020404" pitchFamily="49" charset="0"/>
-              </a:rPr>
-              <a:t>(16, 16)</a:t>
-            </a:r>
-          </a:p>
-        </p:txBody>
-      </p:sp>
-      <p:sp>
-        <p:nvSpPr>
-          <p:cNvPr id="4" name="Slide Number Placeholder 3">
-            <a:extLst>
-              <a:ext uri="{FF2B5EF4-FFF2-40B4-BE49-F238E27FC236}">
-                <a16:creationId xmlns:a16="http://schemas.microsoft.com/office/drawing/2014/main" id="{12E58FCF-8D54-3659-891C-78F762F15A58}"/>
-              </a:ext>
-            </a:extLst>
-          </p:cNvPr>
-          <p:cNvSpPr>
-            <a:spLocks noGrp="1"/>
-          </p:cNvSpPr>
-          <p:nvPr>
-            <p:ph type="sldNum" idx="12"/>
-          </p:nvPr>
-        </p:nvSpPr>
-        <p:spPr/>
-        <p:txBody>
-          <a:bodyPr/>
-          <a:lstStyle/>
-          <a:p>
-            <a:pPr marL="0" lvl="0" indent="0" algn="r" rtl="0">
-              <a:spcBef>
-                <a:spcPts val="0"/>
-              </a:spcBef>
-              <a:spcAft>
-                <a:spcPts val="0"/>
-              </a:spcAft>
-              <a:buNone/>
-            </a:pPr>
-            <a:fld id="{00000000-1234-1234-1234-123412341234}" type="slidenum">
-              <a:rPr lang="en" smtClean="0"/>
-              <a:t>39</a:t>
-            </a:fld>
-            <a:endParaRPr lang="en" dirty="0"/>
-          </a:p>
-        </p:txBody>
-      </p:sp>
-    </p:spTree>
-    <p:extLst>
-      <p:ext uri="{BB962C8B-B14F-4D97-AF65-F5344CB8AC3E}">
-        <p14:creationId xmlns:p14="http://schemas.microsoft.com/office/powerpoint/2010/main" val="184488178"/>
       </p:ext>
     </p:extLst>
   </p:cSld>
@@ -34247,16 +34111,7 @@
           <a:p>
             <a:r>
               <a:rPr lang="en-US" dirty="0"/>
-              <a:t>Require relatively heavyweight installation</a:t>
-            </a:r>
-          </a:p>
-          <a:p>
-            <a:pPr lvl="1"/>
-            <a:r>
-              <a:rPr lang="en-US" dirty="0">
-                <a:latin typeface="Avenir Book" panose="02000503020000020003" pitchFamily="2" charset="0"/>
-              </a:rPr>
-              <a:t>But the cloud sure makes things easy</a:t>
+              <a:t>Server-based databases require system administration</a:t>
             </a:r>
           </a:p>
           <a:p>
@@ -34295,7 +34150,7 @@
           <a:p>
             <a:r>
               <a:rPr lang="en-US" dirty="0"/>
-              <a:t>If database is corrupted (very rare), you’re out of luck</a:t>
+              <a:t>Failures can be catastrophic</a:t>
             </a:r>
           </a:p>
         </p:txBody>
@@ -34373,6 +34228,449 @@
           <p:cNvPr id="2" name="Title 1">
             <a:extLst>
               <a:ext uri="{FF2B5EF4-FFF2-40B4-BE49-F238E27FC236}">
+                <a16:creationId xmlns:a16="http://schemas.microsoft.com/office/drawing/2014/main" id="{82AE8044-E548-A28A-F822-840354C3EDA2}"/>
+              </a:ext>
+            </a:extLst>
+          </p:cNvPr>
+          <p:cNvSpPr>
+            <a:spLocks noGrp="1"/>
+          </p:cNvSpPr>
+          <p:nvPr>
+            <p:ph type="title"/>
+          </p:nvPr>
+        </p:nvSpPr>
+        <p:spPr/>
+        <p:txBody>
+          <a:bodyPr/>
+          <a:lstStyle/>
+          <a:p>
+            <a:r>
+              <a:rPr lang="en-US" dirty="0"/>
+              <a:t>Sample table: Site</a:t>
+            </a:r>
+          </a:p>
+        </p:txBody>
+      </p:sp>
+      <p:sp>
+        <p:nvSpPr>
+          <p:cNvPr id="3" name="Text Placeholder 2">
+            <a:extLst>
+              <a:ext uri="{FF2B5EF4-FFF2-40B4-BE49-F238E27FC236}">
+                <a16:creationId xmlns:a16="http://schemas.microsoft.com/office/drawing/2014/main" id="{F01855C6-2F79-74CE-4597-783180FA08E2}"/>
+              </a:ext>
+            </a:extLst>
+          </p:cNvPr>
+          <p:cNvSpPr>
+            <a:spLocks noGrp="1"/>
+          </p:cNvSpPr>
+          <p:nvPr>
+            <p:ph type="body" idx="1"/>
+          </p:nvPr>
+        </p:nvSpPr>
+        <p:spPr/>
+        <p:txBody>
+          <a:bodyPr>
+            <a:normAutofit fontScale="62500" lnSpcReduction="20000"/>
+          </a:bodyPr>
+          <a:lstStyle/>
+          <a:p>
+            <a:r>
+              <a:rPr lang="en-US" dirty="0"/>
+              <a:t>“ASDN field sites are referred to by 4-letter codes in each of the data files”</a:t>
+            </a:r>
+          </a:p>
+          <a:p>
+            <a:pPr lvl="1"/>
+            <a:endParaRPr lang="en-US" dirty="0">
+              <a:latin typeface="Avenir Book" panose="02000503020000020003" pitchFamily="2" charset="0"/>
+            </a:endParaRPr>
+          </a:p>
+          <a:p>
+            <a:r>
+              <a:rPr lang="en-US" dirty="0">
+                <a:latin typeface="Courier New" panose="02070309020205020404" pitchFamily="49" charset="0"/>
+                <a:cs typeface="Courier New" panose="02070309020205020404" pitchFamily="49" charset="0"/>
+              </a:rPr>
+              <a:t>import pandas as pd</a:t>
+            </a:r>
+            <a:br>
+              <a:rPr lang="en-US" dirty="0">
+                <a:latin typeface="Courier New" panose="02070309020205020404" pitchFamily="49" charset="0"/>
+                <a:cs typeface="Courier New" panose="02070309020205020404" pitchFamily="49" charset="0"/>
+              </a:rPr>
+            </a:br>
+            <a:r>
+              <a:rPr lang="en-US" dirty="0" err="1">
+                <a:latin typeface="Courier New" panose="02070309020205020404" pitchFamily="49" charset="0"/>
+                <a:cs typeface="Courier New" panose="02070309020205020404" pitchFamily="49" charset="0"/>
+              </a:rPr>
+              <a:t>df</a:t>
+            </a:r>
+            <a:r>
+              <a:rPr lang="en-US" dirty="0">
+                <a:latin typeface="Courier New" panose="02070309020205020404" pitchFamily="49" charset="0"/>
+                <a:cs typeface="Courier New" panose="02070309020205020404" pitchFamily="49" charset="0"/>
+              </a:rPr>
+              <a:t> = </a:t>
+            </a:r>
+            <a:r>
+              <a:rPr lang="en-US" dirty="0" err="1">
+                <a:latin typeface="Courier New" panose="02070309020205020404" pitchFamily="49" charset="0"/>
+                <a:cs typeface="Courier New" panose="02070309020205020404" pitchFamily="49" charset="0"/>
+              </a:rPr>
+              <a:t>pd.read_csv</a:t>
+            </a:r>
+            <a:r>
+              <a:rPr lang="en-US" dirty="0">
+                <a:latin typeface="Courier New" panose="02070309020205020404" pitchFamily="49" charset="0"/>
+                <a:cs typeface="Courier New" panose="02070309020205020404" pitchFamily="49" charset="0"/>
+              </a:rPr>
+              <a:t>("</a:t>
+            </a:r>
+            <a:r>
+              <a:rPr lang="en-US" dirty="0" err="1">
+                <a:latin typeface="Courier New" panose="02070309020205020404" pitchFamily="49" charset="0"/>
+                <a:cs typeface="Courier New" panose="02070309020205020404" pitchFamily="49" charset="0"/>
+              </a:rPr>
+              <a:t>site.csv</a:t>
+            </a:r>
+            <a:r>
+              <a:rPr lang="en-US" dirty="0">
+                <a:latin typeface="Courier New" panose="02070309020205020404" pitchFamily="49" charset="0"/>
+                <a:cs typeface="Courier New" panose="02070309020205020404" pitchFamily="49" charset="0"/>
+              </a:rPr>
+              <a:t>")</a:t>
+            </a:r>
+            <a:br>
+              <a:rPr lang="en-US" dirty="0">
+                <a:latin typeface="Courier New" panose="02070309020205020404" pitchFamily="49" charset="0"/>
+                <a:cs typeface="Courier New" panose="02070309020205020404" pitchFamily="49" charset="0"/>
+              </a:rPr>
+            </a:br>
+            <a:r>
+              <a:rPr lang="en-US" dirty="0" err="1">
+                <a:latin typeface="Courier New" panose="02070309020205020404" pitchFamily="49" charset="0"/>
+                <a:cs typeface="Courier New" panose="02070309020205020404" pitchFamily="49" charset="0"/>
+              </a:rPr>
+              <a:t>df.info</a:t>
+            </a:r>
+            <a:r>
+              <a:rPr lang="en-US" dirty="0">
+                <a:latin typeface="Courier New" panose="02070309020205020404" pitchFamily="49" charset="0"/>
+                <a:cs typeface="Courier New" panose="02070309020205020404" pitchFamily="49" charset="0"/>
+              </a:rPr>
+              <a:t>()</a:t>
+            </a:r>
+          </a:p>
+          <a:p>
+            <a:pPr lvl="1"/>
+            <a:endParaRPr lang="en-US" dirty="0">
+              <a:latin typeface="Avenir Book" panose="02000503020000020003" pitchFamily="2" charset="0"/>
+            </a:endParaRPr>
+          </a:p>
+          <a:p>
+            <a:r>
+              <a:rPr lang="en-US" dirty="0"/>
+              <a:t>➜ </a:t>
+            </a:r>
+            <a:r>
+              <a:rPr lang="en-US" dirty="0">
+                <a:latin typeface="Courier New" panose="02070309020205020404" pitchFamily="49" charset="0"/>
+                <a:cs typeface="Courier New" panose="02070309020205020404" pitchFamily="49" charset="0"/>
+              </a:rPr>
+              <a:t>Data columns (total 6 columns):</a:t>
+            </a:r>
+            <a:br>
+              <a:rPr lang="en-US" dirty="0">
+                <a:latin typeface="Courier New" panose="02070309020205020404" pitchFamily="49" charset="0"/>
+                <a:cs typeface="Courier New" panose="02070309020205020404" pitchFamily="49" charset="0"/>
+              </a:rPr>
+            </a:br>
+            <a:r>
+              <a:rPr lang="en-US" dirty="0">
+                <a:latin typeface="Courier New" panose="02070309020205020404" pitchFamily="49" charset="0"/>
+                <a:cs typeface="Courier New" panose="02070309020205020404" pitchFamily="49" charset="0"/>
+              </a:rPr>
+              <a:t> #   Column                      Non-Null Count  </a:t>
+            </a:r>
+            <a:r>
+              <a:rPr lang="en-US" dirty="0" err="1">
+                <a:latin typeface="Courier New" panose="02070309020205020404" pitchFamily="49" charset="0"/>
+                <a:cs typeface="Courier New" panose="02070309020205020404" pitchFamily="49" charset="0"/>
+              </a:rPr>
+              <a:t>Dtype</a:t>
+            </a:r>
+            <a:r>
+              <a:rPr lang="en-US" dirty="0">
+                <a:latin typeface="Courier New" panose="02070309020205020404" pitchFamily="49" charset="0"/>
+                <a:cs typeface="Courier New" panose="02070309020205020404" pitchFamily="49" charset="0"/>
+              </a:rPr>
+              <a:t>  </a:t>
+            </a:r>
+            <a:br>
+              <a:rPr lang="en-US" dirty="0">
+                <a:latin typeface="Courier New" panose="02070309020205020404" pitchFamily="49" charset="0"/>
+                <a:cs typeface="Courier New" panose="02070309020205020404" pitchFamily="49" charset="0"/>
+              </a:rPr>
+            </a:br>
+            <a:r>
+              <a:rPr lang="en-US" dirty="0">
+                <a:latin typeface="Courier New" panose="02070309020205020404" pitchFamily="49" charset="0"/>
+                <a:cs typeface="Courier New" panose="02070309020205020404" pitchFamily="49" charset="0"/>
+              </a:rPr>
+              <a:t>---  ------                      --------------  -----  </a:t>
+            </a:r>
+            <a:br>
+              <a:rPr lang="en-US" dirty="0">
+                <a:latin typeface="Courier New" panose="02070309020205020404" pitchFamily="49" charset="0"/>
+                <a:cs typeface="Courier New" panose="02070309020205020404" pitchFamily="49" charset="0"/>
+              </a:rPr>
+            </a:br>
+            <a:r>
+              <a:rPr lang="en-US" dirty="0">
+                <a:latin typeface="Courier New" panose="02070309020205020404" pitchFamily="49" charset="0"/>
+                <a:cs typeface="Courier New" panose="02070309020205020404" pitchFamily="49" charset="0"/>
+              </a:rPr>
+              <a:t> 0   Code                        16 non-null     object </a:t>
+            </a:r>
+            <a:br>
+              <a:rPr lang="en-US" dirty="0">
+                <a:latin typeface="Courier New" panose="02070309020205020404" pitchFamily="49" charset="0"/>
+                <a:cs typeface="Courier New" panose="02070309020205020404" pitchFamily="49" charset="0"/>
+              </a:rPr>
+            </a:br>
+            <a:r>
+              <a:rPr lang="en-US" dirty="0">
+                <a:latin typeface="Courier New" panose="02070309020205020404" pitchFamily="49" charset="0"/>
+                <a:cs typeface="Courier New" panose="02070309020205020404" pitchFamily="49" charset="0"/>
+              </a:rPr>
+              <a:t> 1   Site name                   16 non-null     object </a:t>
+            </a:r>
+            <a:br>
+              <a:rPr lang="en-US" dirty="0">
+                <a:latin typeface="Courier New" panose="02070309020205020404" pitchFamily="49" charset="0"/>
+                <a:cs typeface="Courier New" panose="02070309020205020404" pitchFamily="49" charset="0"/>
+              </a:rPr>
+            </a:br>
+            <a:r>
+              <a:rPr lang="en-US" dirty="0">
+                <a:latin typeface="Courier New" panose="02070309020205020404" pitchFamily="49" charset="0"/>
+                <a:cs typeface="Courier New" panose="02070309020205020404" pitchFamily="49" charset="0"/>
+              </a:rPr>
+              <a:t> 2   Location                    16 non-null     object </a:t>
+            </a:r>
+            <a:br>
+              <a:rPr lang="en-US" dirty="0">
+                <a:latin typeface="Courier New" panose="02070309020205020404" pitchFamily="49" charset="0"/>
+                <a:cs typeface="Courier New" panose="02070309020205020404" pitchFamily="49" charset="0"/>
+              </a:rPr>
+            </a:br>
+            <a:r>
+              <a:rPr lang="en-US" dirty="0">
+                <a:latin typeface="Courier New" panose="02070309020205020404" pitchFamily="49" charset="0"/>
+                <a:cs typeface="Courier New" panose="02070309020205020404" pitchFamily="49" charset="0"/>
+              </a:rPr>
+              <a:t> 3   Latitude                    16 non-null     float64</a:t>
+            </a:r>
+            <a:br>
+              <a:rPr lang="en-US" dirty="0">
+                <a:latin typeface="Courier New" panose="02070309020205020404" pitchFamily="49" charset="0"/>
+                <a:cs typeface="Courier New" panose="02070309020205020404" pitchFamily="49" charset="0"/>
+              </a:rPr>
+            </a:br>
+            <a:r>
+              <a:rPr lang="en-US" dirty="0">
+                <a:latin typeface="Courier New" panose="02070309020205020404" pitchFamily="49" charset="0"/>
+                <a:cs typeface="Courier New" panose="02070309020205020404" pitchFamily="49" charset="0"/>
+              </a:rPr>
+              <a:t> 4   Longitude                   16 non-null     float64</a:t>
+            </a:r>
+            <a:br>
+              <a:rPr lang="en-US" dirty="0">
+                <a:latin typeface="Courier New" panose="02070309020205020404" pitchFamily="49" charset="0"/>
+                <a:cs typeface="Courier New" panose="02070309020205020404" pitchFamily="49" charset="0"/>
+              </a:rPr>
+            </a:br>
+            <a:r>
+              <a:rPr lang="en-US" dirty="0">
+                <a:latin typeface="Courier New" panose="02070309020205020404" pitchFamily="49" charset="0"/>
+                <a:cs typeface="Courier New" panose="02070309020205020404" pitchFamily="49" charset="0"/>
+              </a:rPr>
+              <a:t> 5   </a:t>
+            </a:r>
+            <a:r>
+              <a:rPr lang="en-US" dirty="0" err="1">
+                <a:latin typeface="Courier New" panose="02070309020205020404" pitchFamily="49" charset="0"/>
+                <a:cs typeface="Courier New" panose="02070309020205020404" pitchFamily="49" charset="0"/>
+              </a:rPr>
+              <a:t>Total_Study_Plot_Area</a:t>
+            </a:r>
+            <a:r>
+              <a:rPr lang="en-US" dirty="0">
+                <a:latin typeface="Courier New" panose="02070309020205020404" pitchFamily="49" charset="0"/>
+                <a:cs typeface="Courier New" panose="02070309020205020404" pitchFamily="49" charset="0"/>
+              </a:rPr>
+              <a:t>_(ha)  16 non-null     float64</a:t>
+            </a:r>
+          </a:p>
+          <a:p>
+            <a:pPr lvl="1"/>
+            <a:endParaRPr lang="en-US" dirty="0">
+              <a:latin typeface="Avenir Book" panose="02000503020000020003" pitchFamily="2" charset="0"/>
+            </a:endParaRPr>
+          </a:p>
+          <a:p>
+            <a:r>
+              <a:rPr lang="en-US" dirty="0" err="1">
+                <a:latin typeface="Courier New" panose="02070309020205020404" pitchFamily="49" charset="0"/>
+                <a:cs typeface="Courier New" panose="02070309020205020404" pitchFamily="49" charset="0"/>
+              </a:rPr>
+              <a:t>len</a:t>
+            </a:r>
+            <a:r>
+              <a:rPr lang="en-US" dirty="0">
+                <a:latin typeface="Courier New" panose="02070309020205020404" pitchFamily="49" charset="0"/>
+                <a:cs typeface="Courier New" panose="02070309020205020404" pitchFamily="49" charset="0"/>
+              </a:rPr>
+              <a:t>(</a:t>
+            </a:r>
+            <a:r>
+              <a:rPr lang="en-US" dirty="0" err="1">
+                <a:latin typeface="Courier New" panose="02070309020205020404" pitchFamily="49" charset="0"/>
+                <a:cs typeface="Courier New" panose="02070309020205020404" pitchFamily="49" charset="0"/>
+              </a:rPr>
+              <a:t>df.Code.unique</a:t>
+            </a:r>
+            <a:r>
+              <a:rPr lang="en-US" dirty="0">
+                <a:latin typeface="Courier New" panose="02070309020205020404" pitchFamily="49" charset="0"/>
+                <a:cs typeface="Courier New" panose="02070309020205020404" pitchFamily="49" charset="0"/>
+              </a:rPr>
+              <a:t>()), </a:t>
+            </a:r>
+            <a:r>
+              <a:rPr lang="en-US" dirty="0" err="1">
+                <a:latin typeface="Courier New" panose="02070309020205020404" pitchFamily="49" charset="0"/>
+                <a:cs typeface="Courier New" panose="02070309020205020404" pitchFamily="49" charset="0"/>
+              </a:rPr>
+              <a:t>len</a:t>
+            </a:r>
+            <a:r>
+              <a:rPr lang="en-US" dirty="0">
+                <a:latin typeface="Courier New" panose="02070309020205020404" pitchFamily="49" charset="0"/>
+                <a:cs typeface="Courier New" panose="02070309020205020404" pitchFamily="49" charset="0"/>
+              </a:rPr>
+              <a:t>(</a:t>
+            </a:r>
+            <a:r>
+              <a:rPr lang="en-US" dirty="0" err="1">
+                <a:latin typeface="Courier New" panose="02070309020205020404" pitchFamily="49" charset="0"/>
+                <a:cs typeface="Courier New" panose="02070309020205020404" pitchFamily="49" charset="0"/>
+              </a:rPr>
+              <a:t>df</a:t>
+            </a:r>
+            <a:r>
+              <a:rPr lang="en-US" dirty="0">
+                <a:latin typeface="Courier New" panose="02070309020205020404" pitchFamily="49" charset="0"/>
+                <a:cs typeface="Courier New" panose="02070309020205020404" pitchFamily="49" charset="0"/>
+              </a:rPr>
+              <a:t>["Site name"].unique())</a:t>
+            </a:r>
+          </a:p>
+          <a:p>
+            <a:pPr lvl="1"/>
+            <a:endParaRPr lang="en-US" dirty="0">
+              <a:latin typeface="Avenir Book" panose="02000503020000020003" pitchFamily="2" charset="0"/>
+            </a:endParaRPr>
+          </a:p>
+          <a:p>
+            <a:r>
+              <a:rPr lang="en-US" dirty="0"/>
+              <a:t>➜ </a:t>
+            </a:r>
+            <a:r>
+              <a:rPr lang="en-US" dirty="0">
+                <a:latin typeface="Courier New" panose="02070309020205020404" pitchFamily="49" charset="0"/>
+                <a:cs typeface="Courier New" panose="02070309020205020404" pitchFamily="49" charset="0"/>
+              </a:rPr>
+              <a:t>(16, 16)</a:t>
+            </a:r>
+          </a:p>
+        </p:txBody>
+      </p:sp>
+      <p:sp>
+        <p:nvSpPr>
+          <p:cNvPr id="4" name="Slide Number Placeholder 3">
+            <a:extLst>
+              <a:ext uri="{FF2B5EF4-FFF2-40B4-BE49-F238E27FC236}">
+                <a16:creationId xmlns:a16="http://schemas.microsoft.com/office/drawing/2014/main" id="{12E58FCF-8D54-3659-891C-78F762F15A58}"/>
+              </a:ext>
+            </a:extLst>
+          </p:cNvPr>
+          <p:cNvSpPr>
+            <a:spLocks noGrp="1"/>
+          </p:cNvSpPr>
+          <p:nvPr>
+            <p:ph type="sldNum" idx="12"/>
+          </p:nvPr>
+        </p:nvSpPr>
+        <p:spPr/>
+        <p:txBody>
+          <a:bodyPr/>
+          <a:lstStyle/>
+          <a:p>
+            <a:pPr marL="0" lvl="0" indent="0" algn="r" rtl="0">
+              <a:spcBef>
+                <a:spcPts val="0"/>
+              </a:spcBef>
+              <a:spcAft>
+                <a:spcPts val="0"/>
+              </a:spcAft>
+              <a:buNone/>
+            </a:pPr>
+            <a:fld id="{00000000-1234-1234-1234-123412341234}" type="slidenum">
+              <a:rPr lang="en" smtClean="0"/>
+              <a:t>40</a:t>
+            </a:fld>
+            <a:endParaRPr lang="en" dirty="0"/>
+          </a:p>
+        </p:txBody>
+      </p:sp>
+    </p:spTree>
+    <p:extLst>
+      <p:ext uri="{BB962C8B-B14F-4D97-AF65-F5344CB8AC3E}">
+        <p14:creationId xmlns:p14="http://schemas.microsoft.com/office/powerpoint/2010/main" val="184488178"/>
+      </p:ext>
+    </p:extLst>
+  </p:cSld>
+  <p:clrMapOvr>
+    <a:masterClrMapping/>
+  </p:clrMapOvr>
+</p:sld>
+</file>
+
+<file path=ppt/slides/slide41.xml><?xml version="1.0" encoding="utf-8"?>
+<p:sld xmlns:a="http://schemas.openxmlformats.org/drawingml/2006/main" xmlns:r="http://schemas.openxmlformats.org/officeDocument/2006/relationships" xmlns:p="http://schemas.openxmlformats.org/presentationml/2006/main">
+  <p:cSld>
+    <p:spTree>
+      <p:nvGrpSpPr>
+        <p:cNvPr id="1" name=""/>
+        <p:cNvGrpSpPr/>
+        <p:nvPr/>
+      </p:nvGrpSpPr>
+      <p:grpSpPr>
+        <a:xfrm>
+          <a:off x="0" y="0"/>
+          <a:ext cx="0" cy="0"/>
+          <a:chOff x="0" y="0"/>
+          <a:chExt cx="0" cy="0"/>
+        </a:xfrm>
+      </p:grpSpPr>
+      <p:sp>
+        <p:nvSpPr>
+          <p:cNvPr id="2" name="Title 1">
+            <a:extLst>
+              <a:ext uri="{FF2B5EF4-FFF2-40B4-BE49-F238E27FC236}">
                 <a16:creationId xmlns:a16="http://schemas.microsoft.com/office/drawing/2014/main" id="{CFB186B3-ED6C-D467-C283-CDF3AB1AA694}"/>
               </a:ext>
             </a:extLst>
@@ -34564,7 +34862,7 @@
             </a:pPr>
             <a:fld id="{00000000-1234-1234-1234-123412341234}" type="slidenum">
               <a:rPr lang="en" smtClean="0"/>
-              <a:t>40</a:t>
+              <a:t>41</a:t>
             </a:fld>
             <a:endParaRPr lang="en" dirty="0"/>
           </a:p>
@@ -34583,7 +34881,7 @@
 </p:sld>
 </file>
 
-<file path=ppt/slides/slide41.xml><?xml version="1.0" encoding="utf-8"?>
+<file path=ppt/slides/slide42.xml><?xml version="1.0" encoding="utf-8"?>
 <p:sld xmlns:a="http://schemas.openxmlformats.org/drawingml/2006/main" xmlns:r="http://schemas.openxmlformats.org/officeDocument/2006/relationships" xmlns:p="http://schemas.openxmlformats.org/presentationml/2006/main">
   <p:cSld>
     <p:spTree>
@@ -34849,7 +35147,7 @@
             </a:pPr>
             <a:fld id="{00000000-1234-1234-1234-123412341234}" type="slidenum">
               <a:rPr lang="en" smtClean="0"/>
-              <a:t>41</a:t>
+              <a:t>42</a:t>
             </a:fld>
             <a:endParaRPr lang="en" dirty="0"/>
           </a:p>
@@ -34868,7 +35166,7 @@
 </p:sld>
 </file>
 
-<file path=ppt/slides/slide42.xml><?xml version="1.0" encoding="utf-8"?>
+<file path=ppt/slides/slide43.xml><?xml version="1.0" encoding="utf-8"?>
 <p:sld xmlns:a="http://schemas.openxmlformats.org/drawingml/2006/main" xmlns:r="http://schemas.openxmlformats.org/officeDocument/2006/relationships" xmlns:p="http://schemas.openxmlformats.org/presentationml/2006/main">
   <p:cSld>
     <p:spTree>
@@ -35034,7 +35332,7 @@
             </a:pPr>
             <a:fld id="{00000000-1234-1234-1234-123412341234}" type="slidenum">
               <a:rPr lang="en" smtClean="0"/>
-              <a:t>42</a:t>
+              <a:t>43</a:t>
             </a:fld>
             <a:endParaRPr lang="en" dirty="0"/>
           </a:p>
@@ -35044,272 +35342,6 @@
     <p:extLst>
       <p:ext uri="{BB962C8B-B14F-4D97-AF65-F5344CB8AC3E}">
         <p14:creationId xmlns:p14="http://schemas.microsoft.com/office/powerpoint/2010/main" val="681495643"/>
-      </p:ext>
-    </p:extLst>
-  </p:cSld>
-  <p:clrMapOvr>
-    <a:masterClrMapping/>
-  </p:clrMapOvr>
-</p:sld>
-</file>
-
-<file path=ppt/slides/slide43.xml><?xml version="1.0" encoding="utf-8"?>
-<p:sld xmlns:a="http://schemas.openxmlformats.org/drawingml/2006/main" xmlns:r="http://schemas.openxmlformats.org/officeDocument/2006/relationships" xmlns:p="http://schemas.openxmlformats.org/presentationml/2006/main">
-  <p:cSld>
-    <p:spTree>
-      <p:nvGrpSpPr>
-        <p:cNvPr id="1" name=""/>
-        <p:cNvGrpSpPr/>
-        <p:nvPr/>
-      </p:nvGrpSpPr>
-      <p:grpSpPr>
-        <a:xfrm>
-          <a:off x="0" y="0"/>
-          <a:ext cx="0" cy="0"/>
-          <a:chOff x="0" y="0"/>
-          <a:chExt cx="0" cy="0"/>
-        </a:xfrm>
-      </p:grpSpPr>
-      <p:sp>
-        <p:nvSpPr>
-          <p:cNvPr id="2" name="Title 1">
-            <a:extLst>
-              <a:ext uri="{FF2B5EF4-FFF2-40B4-BE49-F238E27FC236}">
-                <a16:creationId xmlns:a16="http://schemas.microsoft.com/office/drawing/2014/main" id="{13C5E11B-ED4E-E092-B5AC-3AD01F3AABE6}"/>
-              </a:ext>
-            </a:extLst>
-          </p:cNvPr>
-          <p:cNvSpPr>
-            <a:spLocks noGrp="1"/>
-          </p:cNvSpPr>
-          <p:nvPr>
-            <p:ph type="title"/>
-          </p:nvPr>
-        </p:nvSpPr>
-        <p:spPr/>
-        <p:txBody>
-          <a:bodyPr/>
-          <a:lstStyle/>
-          <a:p>
-            <a:r>
-              <a:rPr lang="en-US" dirty="0"/>
-              <a:t>Why bother with constraints on data? (1)</a:t>
-            </a:r>
-          </a:p>
-        </p:txBody>
-      </p:sp>
-      <p:sp>
-        <p:nvSpPr>
-          <p:cNvPr id="3" name="Text Placeholder 2">
-            <a:extLst>
-              <a:ext uri="{FF2B5EF4-FFF2-40B4-BE49-F238E27FC236}">
-                <a16:creationId xmlns:a16="http://schemas.microsoft.com/office/drawing/2014/main" id="{BA4B172B-B22E-36BA-BAF8-1220759AF9AE}"/>
-              </a:ext>
-            </a:extLst>
-          </p:cNvPr>
-          <p:cNvSpPr>
-            <a:spLocks noGrp="1"/>
-          </p:cNvSpPr>
-          <p:nvPr>
-            <p:ph type="body" idx="1"/>
-          </p:nvPr>
-        </p:nvSpPr>
-        <p:spPr/>
-        <p:txBody>
-          <a:bodyPr/>
-          <a:lstStyle/>
-          <a:p>
-            <a:r>
-              <a:rPr lang="en-US" dirty="0"/>
-              <a:t>Here’s why</a:t>
-            </a:r>
-          </a:p>
-          <a:p>
-            <a:pPr lvl="1"/>
-            <a:endParaRPr lang="en-US" dirty="0">
-              <a:latin typeface="Avenir Book" panose="02000503020000020003" pitchFamily="2" charset="0"/>
-            </a:endParaRPr>
-          </a:p>
-          <a:p>
-            <a:r>
-              <a:rPr lang="en-US" dirty="0" err="1"/>
-              <a:t>Daily_pred_lemm.Team_count</a:t>
-            </a:r>
-            <a:endParaRPr lang="en-US" dirty="0"/>
-          </a:p>
-          <a:p>
-            <a:pPr lvl="1"/>
-            <a:r>
-              <a:rPr lang="en-US" dirty="0">
-                <a:latin typeface="Avenir Book" panose="02000503020000020003" pitchFamily="2" charset="0"/>
-              </a:rPr>
-              <a:t>Boolean column: “Did more than one person conduct the survey together?”</a:t>
-            </a:r>
-          </a:p>
-          <a:p>
-            <a:pPr lvl="1"/>
-            <a:endParaRPr lang="en-US" dirty="0">
-              <a:latin typeface="Avenir Book" panose="02000503020000020003" pitchFamily="2" charset="0"/>
-            </a:endParaRPr>
-          </a:p>
-          <a:p>
-            <a:pPr lvl="1"/>
-            <a:r>
-              <a:rPr lang="en-US" dirty="0">
-                <a:latin typeface="Courier New" panose="02070309020205020404" pitchFamily="49" charset="0"/>
-                <a:cs typeface="Courier New" panose="02070309020205020404" pitchFamily="49" charset="0"/>
-              </a:rPr>
-              <a:t>import pandas as pd</a:t>
-            </a:r>
-            <a:br>
-              <a:rPr lang="en-US" dirty="0">
-                <a:latin typeface="Courier New" panose="02070309020205020404" pitchFamily="49" charset="0"/>
-                <a:cs typeface="Courier New" panose="02070309020205020404" pitchFamily="49" charset="0"/>
-              </a:rPr>
-            </a:br>
-            <a:r>
-              <a:rPr lang="en-US" dirty="0" err="1">
-                <a:latin typeface="Courier New" panose="02070309020205020404" pitchFamily="49" charset="0"/>
-                <a:cs typeface="Courier New" panose="02070309020205020404" pitchFamily="49" charset="0"/>
-              </a:rPr>
-              <a:t>df</a:t>
-            </a:r>
-            <a:r>
-              <a:rPr lang="en-US" dirty="0">
-                <a:latin typeface="Courier New" panose="02070309020205020404" pitchFamily="49" charset="0"/>
-                <a:cs typeface="Courier New" panose="02070309020205020404" pitchFamily="49" charset="0"/>
-              </a:rPr>
-              <a:t> = </a:t>
-            </a:r>
-            <a:r>
-              <a:rPr lang="en-US" dirty="0" err="1">
-                <a:latin typeface="Courier New" panose="02070309020205020404" pitchFamily="49" charset="0"/>
-                <a:cs typeface="Courier New" panose="02070309020205020404" pitchFamily="49" charset="0"/>
-              </a:rPr>
-              <a:t>pd.read_csv</a:t>
-            </a:r>
-            <a:r>
-              <a:rPr lang="en-US" dirty="0">
-                <a:latin typeface="Courier New" panose="02070309020205020404" pitchFamily="49" charset="0"/>
-                <a:cs typeface="Courier New" panose="02070309020205020404" pitchFamily="49" charset="0"/>
-              </a:rPr>
-              <a:t>("</a:t>
-            </a:r>
-            <a:r>
-              <a:rPr lang="en-US" dirty="0" err="1">
-                <a:latin typeface="Courier New" panose="02070309020205020404" pitchFamily="49" charset="0"/>
-                <a:cs typeface="Courier New" panose="02070309020205020404" pitchFamily="49" charset="0"/>
-              </a:rPr>
-              <a:t>ASDN_Daily_pred_lemm.csv</a:t>
-            </a:r>
-            <a:r>
-              <a:rPr lang="en-US" dirty="0">
-                <a:latin typeface="Courier New" panose="02070309020205020404" pitchFamily="49" charset="0"/>
-                <a:cs typeface="Courier New" panose="02070309020205020404" pitchFamily="49" charset="0"/>
-              </a:rPr>
-              <a:t>")</a:t>
-            </a:r>
-            <a:br>
-              <a:rPr lang="en-US" dirty="0">
-                <a:latin typeface="Courier New" panose="02070309020205020404" pitchFamily="49" charset="0"/>
-                <a:cs typeface="Courier New" panose="02070309020205020404" pitchFamily="49" charset="0"/>
-              </a:rPr>
-            </a:br>
-            <a:r>
-              <a:rPr lang="en-US" dirty="0" err="1">
-                <a:latin typeface="Courier New" panose="02070309020205020404" pitchFamily="49" charset="0"/>
-                <a:cs typeface="Courier New" panose="02070309020205020404" pitchFamily="49" charset="0"/>
-              </a:rPr>
-              <a:t>df.Team_count.unique</a:t>
-            </a:r>
-            <a:r>
-              <a:rPr lang="en-US" dirty="0">
-                <a:latin typeface="Courier New" panose="02070309020205020404" pitchFamily="49" charset="0"/>
-                <a:cs typeface="Courier New" panose="02070309020205020404" pitchFamily="49" charset="0"/>
-              </a:rPr>
-              <a:t>()</a:t>
-            </a:r>
-          </a:p>
-          <a:p>
-            <a:pPr lvl="1"/>
-            <a:endParaRPr lang="en-US" dirty="0">
-              <a:latin typeface="Avenir Book" panose="02000503020000020003" pitchFamily="2" charset="0"/>
-            </a:endParaRPr>
-          </a:p>
-          <a:p>
-            <a:pPr lvl="1"/>
-            <a:r>
-              <a:rPr lang="en-US" dirty="0">
-                <a:latin typeface="Avenir Book" panose="02000503020000020003" pitchFamily="2" charset="0"/>
-              </a:rPr>
-              <a:t>➜ </a:t>
-            </a:r>
-            <a:r>
-              <a:rPr lang="en-US" dirty="0">
-                <a:latin typeface="Courier New" panose="02070309020205020404" pitchFamily="49" charset="0"/>
-                <a:cs typeface="Courier New" panose="02070309020205020404" pitchFamily="49" charset="0"/>
-              </a:rPr>
-              <a:t>array(['n', 'y', nan, 'n ', 'N'], </a:t>
-            </a:r>
-            <a:r>
-              <a:rPr lang="en-US" dirty="0" err="1">
-                <a:latin typeface="Courier New" panose="02070309020205020404" pitchFamily="49" charset="0"/>
-                <a:cs typeface="Courier New" panose="02070309020205020404" pitchFamily="49" charset="0"/>
-              </a:rPr>
-              <a:t>dtype</a:t>
-            </a:r>
-            <a:r>
-              <a:rPr lang="en-US" dirty="0">
-                <a:latin typeface="Courier New" panose="02070309020205020404" pitchFamily="49" charset="0"/>
-                <a:cs typeface="Courier New" panose="02070309020205020404" pitchFamily="49" charset="0"/>
-              </a:rPr>
-              <a:t>=object)</a:t>
-            </a:r>
-          </a:p>
-        </p:txBody>
-      </p:sp>
-      <p:sp>
-        <p:nvSpPr>
-          <p:cNvPr id="4" name="Slide Number Placeholder 3">
-            <a:extLst>
-              <a:ext uri="{FF2B5EF4-FFF2-40B4-BE49-F238E27FC236}">
-                <a16:creationId xmlns:a16="http://schemas.microsoft.com/office/drawing/2014/main" id="{E33612C2-840E-0EFB-6BDD-739D42AC4FB1}"/>
-              </a:ext>
-            </a:extLst>
-          </p:cNvPr>
-          <p:cNvSpPr>
-            <a:spLocks noGrp="1"/>
-          </p:cNvSpPr>
-          <p:nvPr>
-            <p:ph type="sldNum" idx="12"/>
-          </p:nvPr>
-        </p:nvSpPr>
-        <p:spPr/>
-        <p:txBody>
-          <a:bodyPr/>
-          <a:lstStyle/>
-          <a:p>
-            <a:pPr marL="0" lvl="0" indent="0" algn="r" rtl="0">
-              <a:spcBef>
-                <a:spcPts val="0"/>
-              </a:spcBef>
-              <a:spcAft>
-                <a:spcPts val="0"/>
-              </a:spcAft>
-              <a:buNone/>
-            </a:pPr>
-            <a:fld id="{00000000-1234-1234-1234-123412341234}" type="slidenum">
-              <a:rPr lang="en" smtClean="0"/>
-              <a:t>43</a:t>
-            </a:fld>
-            <a:endParaRPr lang="en" dirty="0"/>
-          </a:p>
-        </p:txBody>
-      </p:sp>
-    </p:spTree>
-    <p:extLst>
-      <p:ext uri="{BB962C8B-B14F-4D97-AF65-F5344CB8AC3E}">
-        <p14:creationId xmlns:p14="http://schemas.microsoft.com/office/powerpoint/2010/main" val="1988222347"/>
       </p:ext>
     </p:extLst>
   </p:cSld>
@@ -35359,6 +35391,272 @@
           <a:p>
             <a:r>
               <a:rPr lang="en-US" dirty="0"/>
+              <a:t>Why bother with constraints on data? (1)</a:t>
+            </a:r>
+          </a:p>
+        </p:txBody>
+      </p:sp>
+      <p:sp>
+        <p:nvSpPr>
+          <p:cNvPr id="3" name="Text Placeholder 2">
+            <a:extLst>
+              <a:ext uri="{FF2B5EF4-FFF2-40B4-BE49-F238E27FC236}">
+                <a16:creationId xmlns:a16="http://schemas.microsoft.com/office/drawing/2014/main" id="{BA4B172B-B22E-36BA-BAF8-1220759AF9AE}"/>
+              </a:ext>
+            </a:extLst>
+          </p:cNvPr>
+          <p:cNvSpPr>
+            <a:spLocks noGrp="1"/>
+          </p:cNvSpPr>
+          <p:nvPr>
+            <p:ph type="body" idx="1"/>
+          </p:nvPr>
+        </p:nvSpPr>
+        <p:spPr/>
+        <p:txBody>
+          <a:bodyPr/>
+          <a:lstStyle/>
+          <a:p>
+            <a:r>
+              <a:rPr lang="en-US" dirty="0"/>
+              <a:t>Here’s why</a:t>
+            </a:r>
+          </a:p>
+          <a:p>
+            <a:pPr lvl="1"/>
+            <a:endParaRPr lang="en-US" dirty="0">
+              <a:latin typeface="Avenir Book" panose="02000503020000020003" pitchFamily="2" charset="0"/>
+            </a:endParaRPr>
+          </a:p>
+          <a:p>
+            <a:r>
+              <a:rPr lang="en-US" dirty="0" err="1"/>
+              <a:t>Daily_pred_lemm.Team_count</a:t>
+            </a:r>
+            <a:endParaRPr lang="en-US" dirty="0"/>
+          </a:p>
+          <a:p>
+            <a:pPr lvl="1"/>
+            <a:r>
+              <a:rPr lang="en-US" dirty="0">
+                <a:latin typeface="Avenir Book" panose="02000503020000020003" pitchFamily="2" charset="0"/>
+              </a:rPr>
+              <a:t>Boolean column: “Did more than one person conduct the survey together?”</a:t>
+            </a:r>
+          </a:p>
+          <a:p>
+            <a:pPr lvl="1"/>
+            <a:endParaRPr lang="en-US" dirty="0">
+              <a:latin typeface="Avenir Book" panose="02000503020000020003" pitchFamily="2" charset="0"/>
+            </a:endParaRPr>
+          </a:p>
+          <a:p>
+            <a:pPr lvl="1"/>
+            <a:r>
+              <a:rPr lang="en-US" dirty="0">
+                <a:latin typeface="Courier New" panose="02070309020205020404" pitchFamily="49" charset="0"/>
+                <a:cs typeface="Courier New" panose="02070309020205020404" pitchFamily="49" charset="0"/>
+              </a:rPr>
+              <a:t>import pandas as pd</a:t>
+            </a:r>
+            <a:br>
+              <a:rPr lang="en-US" dirty="0">
+                <a:latin typeface="Courier New" panose="02070309020205020404" pitchFamily="49" charset="0"/>
+                <a:cs typeface="Courier New" panose="02070309020205020404" pitchFamily="49" charset="0"/>
+              </a:rPr>
+            </a:br>
+            <a:r>
+              <a:rPr lang="en-US" dirty="0" err="1">
+                <a:latin typeface="Courier New" panose="02070309020205020404" pitchFamily="49" charset="0"/>
+                <a:cs typeface="Courier New" panose="02070309020205020404" pitchFamily="49" charset="0"/>
+              </a:rPr>
+              <a:t>df</a:t>
+            </a:r>
+            <a:r>
+              <a:rPr lang="en-US" dirty="0">
+                <a:latin typeface="Courier New" panose="02070309020205020404" pitchFamily="49" charset="0"/>
+                <a:cs typeface="Courier New" panose="02070309020205020404" pitchFamily="49" charset="0"/>
+              </a:rPr>
+              <a:t> = </a:t>
+            </a:r>
+            <a:r>
+              <a:rPr lang="en-US" dirty="0" err="1">
+                <a:latin typeface="Courier New" panose="02070309020205020404" pitchFamily="49" charset="0"/>
+                <a:cs typeface="Courier New" panose="02070309020205020404" pitchFamily="49" charset="0"/>
+              </a:rPr>
+              <a:t>pd.read_csv</a:t>
+            </a:r>
+            <a:r>
+              <a:rPr lang="en-US" dirty="0">
+                <a:latin typeface="Courier New" panose="02070309020205020404" pitchFamily="49" charset="0"/>
+                <a:cs typeface="Courier New" panose="02070309020205020404" pitchFamily="49" charset="0"/>
+              </a:rPr>
+              <a:t>("</a:t>
+            </a:r>
+            <a:r>
+              <a:rPr lang="en-US" dirty="0" err="1">
+                <a:latin typeface="Courier New" panose="02070309020205020404" pitchFamily="49" charset="0"/>
+                <a:cs typeface="Courier New" panose="02070309020205020404" pitchFamily="49" charset="0"/>
+              </a:rPr>
+              <a:t>ASDN_Daily_pred_lemm.csv</a:t>
+            </a:r>
+            <a:r>
+              <a:rPr lang="en-US" dirty="0">
+                <a:latin typeface="Courier New" panose="02070309020205020404" pitchFamily="49" charset="0"/>
+                <a:cs typeface="Courier New" panose="02070309020205020404" pitchFamily="49" charset="0"/>
+              </a:rPr>
+              <a:t>")</a:t>
+            </a:r>
+            <a:br>
+              <a:rPr lang="en-US" dirty="0">
+                <a:latin typeface="Courier New" panose="02070309020205020404" pitchFamily="49" charset="0"/>
+                <a:cs typeface="Courier New" panose="02070309020205020404" pitchFamily="49" charset="0"/>
+              </a:rPr>
+            </a:br>
+            <a:r>
+              <a:rPr lang="en-US" dirty="0" err="1">
+                <a:latin typeface="Courier New" panose="02070309020205020404" pitchFamily="49" charset="0"/>
+                <a:cs typeface="Courier New" panose="02070309020205020404" pitchFamily="49" charset="0"/>
+              </a:rPr>
+              <a:t>df.Team_count.unique</a:t>
+            </a:r>
+            <a:r>
+              <a:rPr lang="en-US" dirty="0">
+                <a:latin typeface="Courier New" panose="02070309020205020404" pitchFamily="49" charset="0"/>
+                <a:cs typeface="Courier New" panose="02070309020205020404" pitchFamily="49" charset="0"/>
+              </a:rPr>
+              <a:t>()</a:t>
+            </a:r>
+          </a:p>
+          <a:p>
+            <a:pPr lvl="1"/>
+            <a:endParaRPr lang="en-US" dirty="0">
+              <a:latin typeface="Avenir Book" panose="02000503020000020003" pitchFamily="2" charset="0"/>
+            </a:endParaRPr>
+          </a:p>
+          <a:p>
+            <a:pPr lvl="1"/>
+            <a:r>
+              <a:rPr lang="en-US" dirty="0">
+                <a:latin typeface="Avenir Book" panose="02000503020000020003" pitchFamily="2" charset="0"/>
+              </a:rPr>
+              <a:t>➜ </a:t>
+            </a:r>
+            <a:r>
+              <a:rPr lang="en-US" dirty="0">
+                <a:latin typeface="Courier New" panose="02070309020205020404" pitchFamily="49" charset="0"/>
+                <a:cs typeface="Courier New" panose="02070309020205020404" pitchFamily="49" charset="0"/>
+              </a:rPr>
+              <a:t>array(['n', 'y', nan, 'n ', 'N'], </a:t>
+            </a:r>
+            <a:r>
+              <a:rPr lang="en-US" dirty="0" err="1">
+                <a:latin typeface="Courier New" panose="02070309020205020404" pitchFamily="49" charset="0"/>
+                <a:cs typeface="Courier New" panose="02070309020205020404" pitchFamily="49" charset="0"/>
+              </a:rPr>
+              <a:t>dtype</a:t>
+            </a:r>
+            <a:r>
+              <a:rPr lang="en-US" dirty="0">
+                <a:latin typeface="Courier New" panose="02070309020205020404" pitchFamily="49" charset="0"/>
+                <a:cs typeface="Courier New" panose="02070309020205020404" pitchFamily="49" charset="0"/>
+              </a:rPr>
+              <a:t>=object)</a:t>
+            </a:r>
+          </a:p>
+        </p:txBody>
+      </p:sp>
+      <p:sp>
+        <p:nvSpPr>
+          <p:cNvPr id="4" name="Slide Number Placeholder 3">
+            <a:extLst>
+              <a:ext uri="{FF2B5EF4-FFF2-40B4-BE49-F238E27FC236}">
+                <a16:creationId xmlns:a16="http://schemas.microsoft.com/office/drawing/2014/main" id="{E33612C2-840E-0EFB-6BDD-739D42AC4FB1}"/>
+              </a:ext>
+            </a:extLst>
+          </p:cNvPr>
+          <p:cNvSpPr>
+            <a:spLocks noGrp="1"/>
+          </p:cNvSpPr>
+          <p:nvPr>
+            <p:ph type="sldNum" idx="12"/>
+          </p:nvPr>
+        </p:nvSpPr>
+        <p:spPr/>
+        <p:txBody>
+          <a:bodyPr/>
+          <a:lstStyle/>
+          <a:p>
+            <a:pPr marL="0" lvl="0" indent="0" algn="r" rtl="0">
+              <a:spcBef>
+                <a:spcPts val="0"/>
+              </a:spcBef>
+              <a:spcAft>
+                <a:spcPts val="0"/>
+              </a:spcAft>
+              <a:buNone/>
+            </a:pPr>
+            <a:fld id="{00000000-1234-1234-1234-123412341234}" type="slidenum">
+              <a:rPr lang="en" smtClean="0"/>
+              <a:t>44</a:t>
+            </a:fld>
+            <a:endParaRPr lang="en" dirty="0"/>
+          </a:p>
+        </p:txBody>
+      </p:sp>
+    </p:spTree>
+    <p:extLst>
+      <p:ext uri="{BB962C8B-B14F-4D97-AF65-F5344CB8AC3E}">
+        <p14:creationId xmlns:p14="http://schemas.microsoft.com/office/powerpoint/2010/main" val="1988222347"/>
+      </p:ext>
+    </p:extLst>
+  </p:cSld>
+  <p:clrMapOvr>
+    <a:masterClrMapping/>
+  </p:clrMapOvr>
+</p:sld>
+</file>
+
+<file path=ppt/slides/slide45.xml><?xml version="1.0" encoding="utf-8"?>
+<p:sld xmlns:a="http://schemas.openxmlformats.org/drawingml/2006/main" xmlns:r="http://schemas.openxmlformats.org/officeDocument/2006/relationships" xmlns:p="http://schemas.openxmlformats.org/presentationml/2006/main">
+  <p:cSld>
+    <p:spTree>
+      <p:nvGrpSpPr>
+        <p:cNvPr id="1" name=""/>
+        <p:cNvGrpSpPr/>
+        <p:nvPr/>
+      </p:nvGrpSpPr>
+      <p:grpSpPr>
+        <a:xfrm>
+          <a:off x="0" y="0"/>
+          <a:ext cx="0" cy="0"/>
+          <a:chOff x="0" y="0"/>
+          <a:chExt cx="0" cy="0"/>
+        </a:xfrm>
+      </p:grpSpPr>
+      <p:sp>
+        <p:nvSpPr>
+          <p:cNvPr id="2" name="Title 1">
+            <a:extLst>
+              <a:ext uri="{FF2B5EF4-FFF2-40B4-BE49-F238E27FC236}">
+                <a16:creationId xmlns:a16="http://schemas.microsoft.com/office/drawing/2014/main" id="{13C5E11B-ED4E-E092-B5AC-3AD01F3AABE6}"/>
+              </a:ext>
+            </a:extLst>
+          </p:cNvPr>
+          <p:cNvSpPr>
+            <a:spLocks noGrp="1"/>
+          </p:cNvSpPr>
+          <p:nvPr>
+            <p:ph type="title"/>
+          </p:nvPr>
+        </p:nvSpPr>
+        <p:spPr/>
+        <p:txBody>
+          <a:bodyPr/>
+          <a:lstStyle/>
+          <a:p>
+            <a:r>
+              <a:rPr lang="en-US" dirty="0"/>
               <a:t>Why bother with constraints on data? (2)</a:t>
             </a:r>
           </a:p>
@@ -35635,7 +35933,7 @@
             </a:pPr>
             <a:fld id="{00000000-1234-1234-1234-123412341234}" type="slidenum">
               <a:rPr lang="en" smtClean="0"/>
-              <a:t>44</a:t>
+              <a:t>45</a:t>
             </a:fld>
             <a:endParaRPr lang="en" dirty="0"/>
           </a:p>
@@ -35654,7 +35952,7 @@
 </p:sld>
 </file>
 
-<file path=ppt/slides/slide45.xml><?xml version="1.0" encoding="utf-8"?>
+<file path=ppt/slides/slide46.xml><?xml version="1.0" encoding="utf-8"?>
 <p:sld xmlns:a="http://schemas.openxmlformats.org/drawingml/2006/main" xmlns:r="http://schemas.openxmlformats.org/officeDocument/2006/relationships" xmlns:p="http://schemas.openxmlformats.org/presentationml/2006/main" show="0">
   <p:cSld>
     <p:spTree>
@@ -35771,7 +36069,7 @@
             </a:pPr>
             <a:fld id="{00000000-1234-1234-1234-123412341234}" type="slidenum">
               <a:rPr lang="en" smtClean="0"/>
-              <a:t>45</a:t>
+              <a:t>46</a:t>
             </a:fld>
             <a:endParaRPr lang="en" dirty="0"/>
           </a:p>
@@ -35790,7 +36088,7 @@
 </p:sld>
 </file>
 
-<file path=ppt/slides/slide46.xml><?xml version="1.0" encoding="utf-8"?>
+<file path=ppt/slides/slide47.xml><?xml version="1.0" encoding="utf-8"?>
 <p:sld xmlns:a="http://schemas.openxmlformats.org/drawingml/2006/main" xmlns:r="http://schemas.openxmlformats.org/officeDocument/2006/relationships" xmlns:p="http://schemas.openxmlformats.org/presentationml/2006/main">
   <p:cSld>
     <p:spTree>
@@ -35933,7 +36231,7 @@
             </a:pPr>
             <a:fld id="{00000000-1234-1234-1234-123412341234}" type="slidenum">
               <a:rPr lang="en" smtClean="0"/>
-              <a:t>46</a:t>
+              <a:t>47</a:t>
             </a:fld>
             <a:endParaRPr lang="en"/>
           </a:p>
@@ -36221,8 +36519,12 @@
           </a:p>
           <a:p>
             <a:r>
-              <a:rPr lang="en-US" dirty="0"/>
-              <a:t>Desire a single, unified view of data</a:t>
+              <a:rPr lang="en-US" dirty="0">
+                <a:solidFill>
+                  <a:srgbClr val="FF0000"/>
+                </a:solidFill>
+              </a:rPr>
+              <a:t>Desire a single, unified, consistency-enforced view of data</a:t>
             </a:r>
           </a:p>
         </p:txBody>
@@ -36493,7 +36795,19 @@
           <a:p>
             <a:r>
               <a:rPr lang="en-US" dirty="0"/>
-              <a:t>“To ensure accuracy in data collection and management, data collection systems have to be developed and maintained. For this, data models are needed to support data and computer systems by providing definitions and formats of data. Even though the data modelling phase represents only a relatively small share of the total development effort of data systems, its impact on the final result is probably greater than that of any other phase.” (</a:t>
+              <a:t>“To ensure accuracy in data collection and management, data collection systems have to be developed and maintained. For this, data models are needed to support data and computer systems by providing definitions and formats of data. </a:t>
+            </a:r>
+            <a:r>
+              <a:rPr lang="en-US" dirty="0">
+                <a:solidFill>
+                  <a:srgbClr val="FF0000"/>
+                </a:solidFill>
+              </a:rPr>
+              <a:t>Even though the data modelling phase represents only a relatively small share of the total development effort of data systems, its impact on the final result is probably greater than that of any other phase.</a:t>
+            </a:r>
+            <a:r>
+              <a:rPr lang="en-US" dirty="0"/>
+              <a:t>” (</a:t>
             </a:r>
             <a:r>
               <a:rPr lang="en-US" dirty="0" err="1"/>
@@ -36568,7 +36882,7 @@
 </file>
 
 <file path=ppt/slides/slide9.xml><?xml version="1.0" encoding="utf-8"?>
-<p:sld xmlns:a="http://schemas.openxmlformats.org/drawingml/2006/main" xmlns:r="http://schemas.openxmlformats.org/officeDocument/2006/relationships" xmlns:p="http://schemas.openxmlformats.org/presentationml/2006/main">
+<p:sld xmlns:a="http://schemas.openxmlformats.org/drawingml/2006/main" xmlns:r="http://schemas.openxmlformats.org/officeDocument/2006/relationships" xmlns:p="http://schemas.openxmlformats.org/presentationml/2006/main" show="0">
   <p:cSld>
     <p:spTree>
       <p:nvGrpSpPr>

</xml_diff>

<commit_message>
Update slides for day 2
</commit_message>
<xml_diff>
--- a/modules/week01/slides-01.pptx
+++ b/modules/week01/slides-01.pptx
@@ -2444,7 +2444,23 @@
           <a:p>
             <a:r>
               <a:rPr lang="en-US" dirty="0"/>
-              <a:t>We’re not going to do a data modeling exercise, but will instead focus on how express CSV file semantics in SQL</a:t>
+              <a:t>NCEAS BIEN database schema: https://</a:t>
+            </a:r>
+            <a:r>
+              <a:rPr lang="en-US" dirty="0" err="1"/>
+              <a:t>bien.nceas.ucsb.edu</a:t>
+            </a:r>
+            <a:r>
+              <a:rPr lang="en-US" dirty="0"/>
+              <a:t>/bien/</a:t>
+            </a:r>
+            <a:r>
+              <a:rPr lang="en-US" dirty="0" err="1"/>
+              <a:t>biendata</a:t>
+            </a:r>
+            <a:r>
+              <a:rPr lang="en-US" dirty="0"/>
+              <a:t>/previous-bien-versions/bien-3/bien-3-schema/</a:t>
             </a:r>
           </a:p>
         </p:txBody>
@@ -2452,7 +2468,7 @@
     </p:spTree>
     <p:extLst>
       <p:ext uri="{BB962C8B-B14F-4D97-AF65-F5344CB8AC3E}">
-        <p14:creationId xmlns:p14="http://schemas.microsoft.com/office/powerpoint/2010/main" val="3605006695"/>
+        <p14:creationId xmlns:p14="http://schemas.microsoft.com/office/powerpoint/2010/main" val="2652296305"/>
       </p:ext>
     </p:extLst>
   </p:cSld>
@@ -2588,6 +2604,75 @@
           <a:p>
             <a:r>
               <a:rPr lang="en-US" dirty="0"/>
+              <a:t>We’re not going to do a data modeling exercise, but will instead focus on how express CSV file semantics in SQL</a:t>
+            </a:r>
+          </a:p>
+        </p:txBody>
+      </p:sp>
+    </p:spTree>
+    <p:extLst>
+      <p:ext uri="{BB962C8B-B14F-4D97-AF65-F5344CB8AC3E}">
+        <p14:creationId xmlns:p14="http://schemas.microsoft.com/office/powerpoint/2010/main" val="3605006695"/>
+      </p:ext>
+    </p:extLst>
+  </p:cSld>
+  <p:clrMapOvr>
+    <a:masterClrMapping/>
+  </p:clrMapOvr>
+</p:notes>
+</file>
+
+<file path=ppt/notesSlides/notesSlide31.xml><?xml version="1.0" encoding="utf-8"?>
+<p:notes xmlns:a="http://schemas.openxmlformats.org/drawingml/2006/main" xmlns:r="http://schemas.openxmlformats.org/officeDocument/2006/relationships" xmlns:p="http://schemas.openxmlformats.org/presentationml/2006/main">
+  <p:cSld>
+    <p:spTree>
+      <p:nvGrpSpPr>
+        <p:cNvPr id="1" name=""/>
+        <p:cNvGrpSpPr/>
+        <p:nvPr/>
+      </p:nvGrpSpPr>
+      <p:grpSpPr>
+        <a:xfrm>
+          <a:off x="0" y="0"/>
+          <a:ext cx="0" cy="0"/>
+          <a:chOff x="0" y="0"/>
+          <a:chExt cx="0" cy="0"/>
+        </a:xfrm>
+      </p:grpSpPr>
+      <p:sp>
+        <p:nvSpPr>
+          <p:cNvPr id="2" name="Slide Image Placeholder 1"/>
+          <p:cNvSpPr>
+            <a:spLocks noGrp="1" noRot="1" noChangeAspect="1"/>
+          </p:cNvSpPr>
+          <p:nvPr>
+            <p:ph type="sldImg"/>
+          </p:nvPr>
+        </p:nvSpPr>
+        <p:spPr>
+          <a:xfrm>
+            <a:off x="381000" y="685800"/>
+            <a:ext cx="6096000" cy="3429000"/>
+          </a:xfrm>
+        </p:spPr>
+      </p:sp>
+      <p:sp>
+        <p:nvSpPr>
+          <p:cNvPr id="3" name="Notes Placeholder 2"/>
+          <p:cNvSpPr>
+            <a:spLocks noGrp="1"/>
+          </p:cNvSpPr>
+          <p:nvPr>
+            <p:ph type="body" idx="1"/>
+          </p:nvPr>
+        </p:nvSpPr>
+        <p:spPr/>
+        <p:txBody>
+          <a:bodyPr/>
+          <a:lstStyle/>
+          <a:p>
+            <a:r>
+              <a:rPr lang="en-US" dirty="0"/>
               <a:t>View in RStudio or </a:t>
             </a:r>
             <a:r>
@@ -2611,7 +2696,7 @@
 </p:notes>
 </file>
 
-<file path=ppt/notesSlides/notesSlide31.xml><?xml version="1.0" encoding="utf-8"?>
+<file path=ppt/notesSlides/notesSlide32.xml><?xml version="1.0" encoding="utf-8"?>
 <p:notes xmlns:a="http://schemas.openxmlformats.org/drawingml/2006/main" xmlns:r="http://schemas.openxmlformats.org/officeDocument/2006/relationships" xmlns:p="http://schemas.openxmlformats.org/presentationml/2006/main">
   <p:cSld>
     <p:spTree>
@@ -34138,7 +34223,7 @@
 </file>
 
 <file path=ppt/slides/slide35.xml><?xml version="1.0" encoding="utf-8"?>
-<p:sld xmlns:a="http://schemas.openxmlformats.org/drawingml/2006/main" xmlns:r="http://schemas.openxmlformats.org/officeDocument/2006/relationships" xmlns:p="http://schemas.openxmlformats.org/presentationml/2006/main">
+<p:sld xmlns:a="http://schemas.openxmlformats.org/drawingml/2006/main" xmlns:r="http://schemas.openxmlformats.org/officeDocument/2006/relationships" xmlns:p="http://schemas.openxmlformats.org/presentationml/2006/main" show="0">
   <p:cSld>
     <p:spTree>
       <p:nvGrpSpPr>
@@ -34411,7 +34496,7 @@
           <a:p>
             <a:r>
               <a:rPr lang="en-US" dirty="0"/>
-              <a:t>Diagramming Harry Potter</a:t>
+              <a:t>ER Diagramming</a:t>
             </a:r>
           </a:p>
         </p:txBody>
@@ -34439,25 +34524,19 @@
           <a:p>
             <a:r>
               <a:rPr lang="en-US" dirty="0"/>
-              <a:t>Conceptual</a:t>
-            </a:r>
-          </a:p>
-          <a:p>
-            <a:endParaRPr lang="en-US" dirty="0"/>
-          </a:p>
-          <a:p>
-            <a:endParaRPr lang="en-US" dirty="0"/>
-          </a:p>
-          <a:p>
-            <a:endParaRPr lang="en-US" dirty="0"/>
-          </a:p>
-          <a:p>
-            <a:endParaRPr lang="en-US" dirty="0"/>
+              <a:t>Common, useful way of visualizing a schema</a:t>
+            </a:r>
           </a:p>
           <a:p>
             <a:r>
               <a:rPr lang="en-US" dirty="0"/>
-              <a:t>Physical</a:t>
+              <a:t>Lots of variations on symbology</a:t>
+            </a:r>
+          </a:p>
+          <a:p>
+            <a:r>
+              <a:rPr lang="en-US" dirty="0"/>
+              <a:t>Many-to-one relationship: crow’s foot (many) to single bar (one)</a:t>
             </a:r>
           </a:p>
         </p:txBody>
@@ -34502,39 +34581,10 @@
       </p:sp>
       <p:pic>
         <p:nvPicPr>
-          <p:cNvPr id="19" name="Picture 18" descr="A screenshot of a computer&#10;&#10;Description automatically generated">
+          <p:cNvPr id="6" name="Picture 5">
             <a:extLst>
               <a:ext uri="{FF2B5EF4-FFF2-40B4-BE49-F238E27FC236}">
-                <a16:creationId xmlns:a16="http://schemas.microsoft.com/office/drawing/2014/main" id="{A00748BF-CCFB-5198-EB69-77C0BD06C53F}"/>
-              </a:ext>
-            </a:extLst>
-          </p:cNvPr>
-          <p:cNvPicPr>
-            <a:picLocks noChangeAspect="1"/>
-          </p:cNvPicPr>
-          <p:nvPr/>
-        </p:nvPicPr>
-        <p:blipFill>
-          <a:blip r:embed="rId2"/>
-          <a:srcRect b="24016"/>
-          <a:stretch/>
-        </p:blipFill>
-        <p:spPr>
-          <a:xfrm>
-            <a:off x="2132838" y="1375156"/>
-            <a:ext cx="3086100" cy="1196594"/>
-          </a:xfrm>
-          <a:prstGeom prst="rect">
-            <a:avLst/>
-          </a:prstGeom>
-        </p:spPr>
-      </p:pic>
-      <p:pic>
-        <p:nvPicPr>
-          <p:cNvPr id="21" name="Picture 20" descr="A screen shot of a computer&#10;&#10;Description automatically generated">
-            <a:extLst>
-              <a:ext uri="{FF2B5EF4-FFF2-40B4-BE49-F238E27FC236}">
-                <a16:creationId xmlns:a16="http://schemas.microsoft.com/office/drawing/2014/main" id="{1C24115A-84FC-C256-3188-E205D66BE34A}"/>
+                <a16:creationId xmlns:a16="http://schemas.microsoft.com/office/drawing/2014/main" id="{542548B1-6F99-D9D2-8AAB-16E136B0063F}"/>
               </a:ext>
             </a:extLst>
           </p:cNvPr>
@@ -34545,13 +34595,14 @@
         </p:nvPicPr>
         <p:blipFill>
           <a:blip r:embed="rId3"/>
-          <a:srcRect b="24016"/>
-          <a:stretch/>
+          <a:stretch>
+            <a:fillRect/>
+          </a:stretch>
         </p:blipFill>
         <p:spPr>
           <a:xfrm>
-            <a:off x="1288288" y="3090087"/>
-            <a:ext cx="4775200" cy="1196594"/>
+            <a:off x="616495" y="2778153"/>
+            <a:ext cx="7772400" cy="1416253"/>
           </a:xfrm>
           <a:prstGeom prst="rect">
             <a:avLst/>
@@ -36659,6 +36710,36 @@
           </a:p>
         </p:txBody>
       </p:sp>
+      <p:pic>
+        <p:nvPicPr>
+          <p:cNvPr id="6" name="Picture 5">
+            <a:extLst>
+              <a:ext uri="{FF2B5EF4-FFF2-40B4-BE49-F238E27FC236}">
+                <a16:creationId xmlns:a16="http://schemas.microsoft.com/office/drawing/2014/main" id="{0D66873E-86EE-3DBD-A1AF-76E821AC0C61}"/>
+              </a:ext>
+            </a:extLst>
+          </p:cNvPr>
+          <p:cNvPicPr>
+            <a:picLocks noChangeAspect="1"/>
+          </p:cNvPicPr>
+          <p:nvPr/>
+        </p:nvPicPr>
+        <p:blipFill>
+          <a:blip r:embed="rId2"/>
+          <a:stretch>
+            <a:fillRect/>
+          </a:stretch>
+        </p:blipFill>
+        <p:spPr>
+          <a:xfrm>
+            <a:off x="2255521" y="3199655"/>
+            <a:ext cx="4150904" cy="1660362"/>
+          </a:xfrm>
+          <a:prstGeom prst="rect">
+            <a:avLst/>
+          </a:prstGeom>
+        </p:spPr>
+      </p:pic>
     </p:spTree>
     <p:extLst>
       <p:ext uri="{BB962C8B-B14F-4D97-AF65-F5344CB8AC3E}">

</xml_diff>